<commit_message>
Update slides: add defect gallery slide
</commit_message>
<xml_diff>
--- a/slides/pitch.pptx
+++ b/slides/pitch.pptx
@@ -12,9 +12,10 @@
     <p:sldId id="260" r:id="rId6"/>
     <p:sldId id="261" r:id="rId7"/>
     <p:sldId id="262" r:id="rId8"/>
+    <p:sldId id="263" r:id="rId9"/>
   </p:sldIdLst>
   <p:notesMasterIdLst>
-    <p:notesMasterId r:id="rId9"/>
+    <p:notesMasterId r:id="rId10"/>
   </p:notesMasterIdLst>
   <p:sldSz cx="9144000" cy="5143500"/>
   <p:notesSz cx="5143500" cy="9144000"/>
@@ -596,7 +597,7 @@
           <a:p>
             <a:r>
               <a:rPr lang="en-US" dirty="0"/>
-              <a:t>(about 35 seconds) Defects are rare, labels need experts. NEU has 1,800 images, six defect types. I used five-fold cross-validation, so every image is tested once, from 1 to 240 labelled images per class. Hyper-parameters were fixed before looking at test results. One honest point up front: this dataset is very uniform, every test image has a near-twin in training, so I focus on small label counts and on tests beyond accuracy.</a:t>
+              <a:t>(about 35 seconds) Defects are rare, labels need experts. NEU has 1,800 images, six defect types. I used five-fold cross-validation, so every image is tested once, from 1 to 240 labelled images per class. Hyper-parameters were fixed before looking at test results. One honest point up front: this dataset is very uniform, every test image has a near-twin in training, so I focus on small label counts and on tests beyond accuracy. I chose NEU because it is a published, balanced industrial benchmark small enough for repeated runs; a larger set, GC10-DET, was not reliably downloadable.</a:t>
             </a:r>
             <a:endParaRPr lang="en-US" dirty="0"/>
           </a:p>
@@ -684,7 +685,7 @@
           <a:p>
             <a:r>
               <a:rPr lang="en-US" dirty="0"/>
-              <a:t>(about 35 seconds) Five methods. Zero-shot CLIP uses only text prompts. Frozen CLIP trains only a tiny linear classifier. Partial fine-tuning trains the last two blocks, about 15 million parameters. Full fine-tuning updates all 86 million. An ImageNet pretrained ViT is the reference with different pretraining data. I measured seven things, not just accuracy, and I tuned the frozen baseline fairly, because an untuned baseline would flatter fine-tuning.</a:t>
+              <a:t>(about 20 seconds) This is what the model has to recognise: six kinds of surface defect on hot-rolled steel, 300 images each. Some are large and obvious, like patches; others are subtle, like crazing or a few thin scratches. Each image comes with a label, which is simply its defect name. When I say one label per class, I mean one example image of each of these six defects. With a single example, the hardest were scratches, pitting and inclusion.</a:t>
             </a:r>
             <a:endParaRPr lang="en-US" dirty="0"/>
           </a:p>
@@ -772,7 +773,7 @@
           <a:p>
             <a:r>
               <a:rPr lang="en-US" dirty="0"/>
-              <a:t>(about 40 seconds) Main result. Full fine-tuning of CLIP is best at every budget. At one label per class it is 12.7 points ahead of properly tuned frozen features, with an interval that excludes zero. It reaches 95 percent with 3 labels per class; tuned frozen features need 10. By 50 labels the difference is about one point and not reliable. So the answer to my question depends on label budget: with a handful of labels, fine-tune; with plenty, a tuned frozen encoder is nearly as good at a fraction of the cost.</a:t>
+              <a:t>(about 35 seconds) Five methods. Zero-shot CLIP uses only text prompts. Frozen CLIP trains only a tiny linear classifier. Partial fine-tuning trains the last two blocks, about 15 million parameters. Full fine-tuning updates all 86 million. An ImageNet pretrained ViT is the reference with different pretraining data. I measured seven things, not just accuracy, and I tuned the frozen baseline fairly, because an untuned baseline would flatter fine-tuning. I chose CLIP because its image and text training gives broad features and allows a zero-shot test; the ImageNet model checks whether that pretraining matters; partial and full fine-tuning show how much adaptation is worth.</a:t>
             </a:r>
             <a:endParaRPr lang="en-US" dirty="0"/>
           </a:p>
@@ -860,7 +861,7 @@
           <a:p>
             <a:r>
               <a:rPr lang="en-US" dirty="0"/>
-              <a:t>(about 40 seconds) Three findings beyond accuracy. First, rare defects: with one labelled example, plain fine-tuning finds only 6 percent; class weighting lifts that to 69 percent, so weight your classes. Second, a defect type never seen in training: fine-tuned CLIP separates it best, AUROC 0.96 versus 0.87 for frozen features. Third, a warning: although fine-tuned models are well calibrated overall, 22 percent of their mistakes at one label are made with more than 90 percent confidence. For a factory, that is the failure that matters.</a:t>
+              <a:t>(about 40 seconds) Main result. Full fine-tuning of CLIP is best at every budget. At one label per class it is 12.7 points ahead of properly tuned frozen features, with an interval that excludes zero. It reaches 95 percent with 3 labels per class; tuned frozen features need 10. By 50 labels the difference is about one point and not reliable. So the answer to my question depends on label budget: with a handful of labels, fine-tune; with plenty, a tuned frozen encoder is nearly as good at a fraction of the cost.</a:t>
             </a:r>
             <a:endParaRPr lang="en-US" dirty="0"/>
           </a:p>
@@ -948,7 +949,7 @@
           <a:p>
             <a:r>
               <a:rPr lang="en-US" dirty="0"/>
-              <a:t>(about 35 seconds) Clean accuracy hides fragility. Under heavy blur or noise, accuracy falls to between 40 and 74 percent. Training with blur and noise augmentation fixes those two, up to 97 percent, but it does not fix everything: strong brightening got slightly worse, so this is protection against what you trained for, not general robustness. On ethics: keep a human in the loop for uncertain and novel items, revalidate on every plant, keep responsibility with the quality team, think about data protection if cameras capture workers, and note the compute cost of fine-tuning.</a:t>
+              <a:t>(about 40 seconds) Three findings beyond accuracy. First, rare defects: with one labelled example, plain fine-tuning finds only 6 percent; class weighting lifts that to 69 percent, so weight your classes. Second, a defect type never seen in training: fine-tuned CLIP separates it best, AUROC 0.96 versus 0.87 for frozen features. Third, a warning: although fine-tuned models are well calibrated overall, 22 percent of their mistakes at one label are made with more than 90 percent confidence. For a factory, that is the failure that matters.</a:t>
             </a:r>
             <a:endParaRPr lang="en-US" dirty="0"/>
           </a:p>
@@ -1036,7 +1037,7 @@
           <a:p>
             <a:r>
               <a:rPr lang="en-US" dirty="0"/>
-              <a:t>(about 35 seconds) Take-aways. With one to five labels per class, fully fine-tune a CLIP transformer, and weight rare classes. With 50 or more labels, a tuned frozen encoder is almost as good at much lower cost. Whatever you choose, check calibration, confident errors, novel defects and corruptions rather than accuracy alone. The limits are a single homogeneous dataset and few folds for some tests. Next: a more varied dataset, detection instead of classification, and testing across plants and cameras. Thank you; I am happy to take questions.</a:t>
+              <a:t>(about 35 seconds) Clean accuracy hides fragility. Under heavy blur or noise, accuracy falls to between 40 and 74 percent. Training with blur and noise augmentation fixes those two, up to 97 percent, but it does not fix everything: strong brightening got slightly worse, so this is protection against what you trained for, not general robustness. On ethics: keep a human in the loop for uncertain and novel items, revalidate on every plant, keep responsibility with the quality team, think about data protection if cameras capture workers, and note the compute cost of fine-tuning.</a:t>
             </a:r>
             <a:endParaRPr lang="en-US" dirty="0"/>
           </a:p>
@@ -1060,6 +1061,94 @@
             <a:fld id="{F7021451-1387-4CA6-816F-3879F97B5CBC}" type="slidenum">
               <a:rPr lang="en-US"/>
               <a:t>7</a:t>
+            </a:fld>
+            <a:endParaRPr lang="en-US"/>
+          </a:p>
+        </p:txBody>
+      </p:sp>
+    </p:spTree>
+    <p:extLst>
+      <p:ext uri="{BB962C8B-B14F-4D97-AF65-F5344CB8AC3E}">
+        <p14:creationId xmlns:p14="http://schemas.microsoft.com/office/powerpoint/2010/main" val="1024086991"/>
+      </p:ext>
+    </p:extLst>
+  </p:cSld>
+  <p:clrMapOvr>
+    <a:masterClrMapping/>
+  </p:clrMapOvr>
+</p:notes>
+</file>
+
+<file path=ppt/notesSlides/notesSlide8.xml><?xml version="1.0" encoding="utf-8"?>
+<p:notes xmlns:a="http://schemas.openxmlformats.org/drawingml/2006/main" xmlns:r="http://schemas.openxmlformats.org/officeDocument/2006/relationships" xmlns:p="http://schemas.openxmlformats.org/presentationml/2006/main">
+  <p:cSld>
+    <p:spTree>
+      <p:nvGrpSpPr>
+        <p:cNvPr id="1" name=""/>
+        <p:cNvGrpSpPr/>
+        <p:nvPr/>
+      </p:nvGrpSpPr>
+      <p:grpSpPr>
+        <a:xfrm>
+          <a:off x="0" y="0"/>
+          <a:ext cx="0" cy="0"/>
+          <a:chOff x="0" y="0"/>
+          <a:chExt cx="0" cy="0"/>
+        </a:xfrm>
+      </p:grpSpPr>
+      <p:sp>
+        <p:nvSpPr>
+          <p:cNvPr id="2" name="Slide Image Placeholder 1"/>
+          <p:cNvSpPr>
+            <a:spLocks noGrp="1" noRot="1" noChangeAspect="1"/>
+          </p:cNvSpPr>
+          <p:nvPr>
+            <p:ph type="sldImg"/>
+          </p:nvPr>
+        </p:nvSpPr>
+        <p:spPr/>
+      </p:sp>
+      <p:sp>
+        <p:nvSpPr>
+          <p:cNvPr id="3" name="Notes Placeholder 2"/>
+          <p:cNvSpPr>
+            <a:spLocks noGrp="1"/>
+          </p:cNvSpPr>
+          <p:nvPr>
+            <p:ph type="body" idx="1"/>
+          </p:nvPr>
+        </p:nvSpPr>
+        <p:spPr/>
+        <p:txBody>
+          <a:bodyPr/>
+          <a:lstStyle/>
+          <a:p>
+            <a:r>
+              <a:rPr lang="en-US" dirty="0"/>
+              <a:t>(about 35 seconds) Take-aways. With one to five labels per class, fully fine-tune a CLIP transformer, and weight rare classes. With 50 or more labels, a tuned frozen encoder is almost as good at much lower cost. Whatever you choose, check calibration, confident errors, novel defects and corruptions rather than accuracy alone. The limits are a single homogeneous dataset and few folds for some tests. Next: a more varied dataset, detection instead of classification, and testing across plants and cameras. Thank you; I am happy to take questions.</a:t>
+            </a:r>
+            <a:endParaRPr lang="en-US" dirty="0"/>
+          </a:p>
+        </p:txBody>
+      </p:sp>
+      <p:sp>
+        <p:nvSpPr>
+          <p:cNvPr id="4" name="Slide Number Placeholder 3"/>
+          <p:cNvSpPr>
+            <a:spLocks noGrp="1"/>
+          </p:cNvSpPr>
+          <p:nvPr>
+            <p:ph type="sldNum" sz="quarter" idx="10"/>
+          </p:nvPr>
+        </p:nvSpPr>
+        <p:spPr/>
+        <p:txBody>
+          <a:bodyPr/>
+          <a:lstStyle/>
+          <a:p>
+            <a:fld id="{F7021451-1387-4CA6-816F-3879F97B5CBC}" type="slidenum">
+              <a:rPr lang="en-US"/>
+              <a:t>8</a:t>
             </a:fld>
             <a:endParaRPr lang="en-US"/>
           </a:p>
@@ -1917,8 +2006,8 @@
         </p:nvSpPr>
         <p:spPr>
           <a:xfrm>
-            <a:off x="457200" y="1188720"/>
-            <a:ext cx="4206240" cy="2743200"/>
+            <a:off x="457200" y="1143000"/>
+            <a:ext cx="4297680" cy="3017520"/>
           </a:xfrm>
           <a:prstGeom prst="rect">
             <a:avLst/>
@@ -1932,12 +2021,12 @@
           <a:p>
             <a:pPr indent="0" marL="0">
               <a:spcAft>
-                <a:spcPts val="400"/>
+                <a:spcPts val="500"/>
               </a:spcAft>
               <a:buNone/>
             </a:pPr>
             <a:r>
-              <a:rPr lang="en-US" sz="1500" b="1" dirty="0">
+              <a:rPr lang="en-US" sz="1250" b="1" dirty="0">
                 <a:solidFill>
                   <a:schemeClr val="accent1"/>
                 </a:solidFill>
@@ -1947,17 +2036,17 @@
               </a:rPr>
               <a:t>Question</a:t>
             </a:r>
-            <a:endParaRPr lang="en-US" sz="1500" dirty="0"/>
+            <a:endParaRPr lang="en-US" sz="1250" dirty="0"/>
           </a:p>
           <a:p>
             <a:pPr indent="0" marL="0">
               <a:spcAft>
-                <a:spcPts val="400"/>
+                <a:spcPts val="500"/>
               </a:spcAft>
               <a:buNone/>
             </a:pPr>
             <a:r>
-              <a:rPr lang="en-US" sz="1500" dirty="0">
+              <a:rPr lang="en-US" sz="1250" dirty="0">
                 <a:solidFill>
                   <a:schemeClr val="tx1"/>
                 </a:solidFill>
@@ -1967,67 +2056,87 @@
               </a:rPr>
               <a:t>As labelled images per class shrink from 240 to 1, which way of adapting a pretrained ViT works best, and what does accuracy hide?</a:t>
             </a:r>
-            <a:endParaRPr lang="en-US" sz="1500" dirty="0"/>
+            <a:endParaRPr lang="en-US" sz="1250" dirty="0"/>
           </a:p>
           <a:p>
             <a:pPr indent="0" marL="0">
               <a:spcAft>
-                <a:spcPts val="400"/>
+                <a:spcPts val="500"/>
               </a:spcAft>
               <a:buNone/>
             </a:pPr>
             <a:r>
-              <a:rPr lang="en-US" sz="1500" dirty="0">
-                <a:solidFill>
-                  <a:schemeClr val="tx1"/>
+              <a:rPr lang="en-US" sz="1250" b="1" dirty="0">
+                <a:solidFill>
+                  <a:schemeClr val="accent1"/>
                 </a:solidFill>
                 <a:latin typeface="Calibri" pitchFamily="34" charset="0"/>
                 <a:ea typeface="Calibri" pitchFamily="34" charset="-122"/>
                 <a:cs typeface="Calibri" pitchFamily="34" charset="-120"/>
               </a:rPr>
-              <a:t> </a:t>
-            </a:r>
-            <a:endParaRPr lang="en-US" sz="1500" dirty="0"/>
+              <a:t>Data</a:t>
+            </a:r>
+            <a:endParaRPr lang="en-US" sz="1250" dirty="0"/>
           </a:p>
           <a:p>
             <a:pPr indent="0" marL="0">
               <a:spcAft>
-                <a:spcPts val="400"/>
+                <a:spcPts val="500"/>
               </a:spcAft>
               <a:buNone/>
             </a:pPr>
             <a:r>
-              <a:rPr lang="en-US" sz="1500" b="1" dirty="0">
-                <a:solidFill>
-                  <a:schemeClr val="accent1"/>
+              <a:rPr lang="en-US" sz="1250" dirty="0">
+                <a:solidFill>
+                  <a:schemeClr val="tx1"/>
                 </a:solidFill>
                 <a:latin typeface="Calibri" pitchFamily="34" charset="0"/>
                 <a:ea typeface="Calibri" pitchFamily="34" charset="-122"/>
                 <a:cs typeface="Calibri" pitchFamily="34" charset="-120"/>
               </a:rPr>
-              <a:t>Data</a:t>
-            </a:r>
-            <a:endParaRPr lang="en-US" sz="1500" dirty="0"/>
+              <a:t>NEU surface defects: 1,800 grayscale images, six defect types, 300 each. Very homogeneous, so it saturates near 100%.</a:t>
+            </a:r>
+            <a:endParaRPr lang="en-US" sz="1250" dirty="0"/>
           </a:p>
           <a:p>
             <a:pPr indent="0" marL="0">
               <a:spcAft>
-                <a:spcPts val="400"/>
+                <a:spcPts val="500"/>
               </a:spcAft>
               <a:buNone/>
             </a:pPr>
             <a:r>
-              <a:rPr lang="en-US" sz="1500" dirty="0">
-                <a:solidFill>
-                  <a:schemeClr val="tx1"/>
+              <a:rPr lang="en-US" sz="1250" b="1" dirty="0">
+                <a:solidFill>
+                  <a:schemeClr val="accent1"/>
                 </a:solidFill>
                 <a:latin typeface="Calibri" pitchFamily="34" charset="0"/>
                 <a:ea typeface="Calibri" pitchFamily="34" charset="-122"/>
                 <a:cs typeface="Calibri" pitchFamily="34" charset="-120"/>
               </a:rPr>
-              <a:t>NEU surface defects: 1,800 grayscale images, six defect types, 300 each. Very homogeneous, so it saturates near 100%.</a:t>
-            </a:r>
-            <a:endParaRPr lang="en-US" sz="1500" dirty="0"/>
+              <a:t>Why NEU</a:t>
+            </a:r>
+            <a:endParaRPr lang="en-US" sz="1250" dirty="0"/>
+          </a:p>
+          <a:p>
+            <a:pPr indent="0" marL="0">
+              <a:spcAft>
+                <a:spcPts val="500"/>
+              </a:spcAft>
+              <a:buNone/>
+            </a:pPr>
+            <a:r>
+              <a:rPr lang="en-US" sz="1250" dirty="0">
+                <a:solidFill>
+                  <a:schemeClr val="tx1"/>
+                </a:solidFill>
+                <a:latin typeface="Calibri" pitchFamily="34" charset="0"/>
+                <a:ea typeface="Calibri" pitchFamily="34" charset="-122"/>
+                <a:cs typeface="Calibri" pitchFamily="34" charset="-120"/>
+              </a:rPr>
+              <a:t>Published industrial benchmark, balanced, small enough for repeated runs on a laptop. GC10-DET was considered but could not be downloaded reliably.</a:t>
+            </a:r>
+            <a:endParaRPr lang="en-US" sz="1250" dirty="0"/>
           </a:p>
         </p:txBody>
       </p:sp>
@@ -2592,7 +2701,7 @@
                   <a:srgbClr val="1F2A33"/>
                 </a:solidFill>
               </a:rPr>
-              <a:t>Five ways to use a pretrained transformer, compared on identical splits</a:t>
+              <a:t>The data: six kinds of steel surface defect, 300 images each</a:t>
             </a:r>
             <a:endParaRPr lang="en-US" sz="2400" dirty="0"/>
           </a:p>
@@ -2606,12 +2715,12 @@
         </p:nvSpPr>
         <p:spPr>
           <a:xfrm>
-            <a:off x="457200" y="1234440"/>
-            <a:ext cx="1536192" cy="1920240"/>
+            <a:off x="457200" y="1188720"/>
+            <a:ext cx="1280160" cy="2514600"/>
           </a:xfrm>
           <a:prstGeom prst="roundRect">
             <a:avLst>
-              <a:gd name="adj" fmla="val 4762"/>
+              <a:gd name="adj" fmla="val 5714"/>
             </a:avLst>
           </a:prstGeom>
           <a:solidFill>
@@ -2625,57 +2734,56 @@
           </a:ln>
         </p:spPr>
       </p:sp>
-      <p:sp>
-        <p:nvSpPr>
-          <p:cNvPr id="4" name="Shape 2"/>
-          <p:cNvSpPr/>
-          <p:nvPr/>
-        </p:nvSpPr>
-        <p:spPr>
-          <a:xfrm>
-            <a:off x="457200" y="1234440"/>
-            <a:ext cx="1536192" cy="82296"/>
-          </a:xfrm>
-          <a:prstGeom prst="rect">
-            <a:avLst/>
-          </a:prstGeom>
-          <a:solidFill>
-            <a:schemeClr val="accent3"/>
-          </a:solidFill>
-          <a:ln w="12700">
-            <a:solidFill>
-              <a:schemeClr val="accent3"/>
-            </a:solidFill>
-            <a:prstDash val="solid"/>
-          </a:ln>
-        </p:spPr>
-      </p:sp>
-      <p:sp>
-        <p:nvSpPr>
-          <p:cNvPr id="5" name="Text 3"/>
-          <p:cNvSpPr txBox="1"/>
-          <p:nvPr/>
-        </p:nvSpPr>
-        <p:spPr>
-          <a:xfrm>
-            <a:off x="566928" y="1417320"/>
-            <a:ext cx="1325880" cy="548640"/>
-          </a:xfrm>
-          <a:prstGeom prst="rect">
-            <a:avLst/>
-          </a:prstGeom>
-          <a:noFill/>
-          <a:ln/>
-        </p:spPr>
-        <p:txBody>
-          <a:bodyPr wrap="square" lIns="0" tIns="0" rIns="0" bIns="0" rtlCol="0" anchor="t"/>
-          <a:lstStyle/>
-          <a:p>
-            <a:pPr indent="0" marL="0">
-              <a:buNone/>
-            </a:pPr>
-            <a:r>
-              <a:rPr lang="en-US" sz="1400" b="1" dirty="0">
+      <p:pic>
+        <p:nvPicPr>
+          <p:cNvPr id="4" name="Image 0" descr="/home/claude/fig/defect_crazing.png">    </p:cNvPr>
+          <p:cNvPicPr>
+            <a:picLocks noChangeAspect="1"/>
+          </p:cNvPicPr>
+          <p:nvPr/>
+        </p:nvPicPr>
+        <p:blipFill>
+          <a:blip r:embed="rId1"/>
+          <a:stretch>
+            <a:fillRect/>
+          </a:stretch>
+        </p:blipFill>
+        <p:spPr>
+          <a:xfrm>
+            <a:off x="548640" y="1280160"/>
+            <a:ext cx="1097280" cy="1097280"/>
+          </a:xfrm>
+          <a:prstGeom prst="rect">
+            <a:avLst/>
+          </a:prstGeom>
+        </p:spPr>
+      </p:pic>
+      <p:sp>
+        <p:nvSpPr>
+          <p:cNvPr id="5" name="Text 2"/>
+          <p:cNvSpPr txBox="1"/>
+          <p:nvPr/>
+        </p:nvSpPr>
+        <p:spPr>
+          <a:xfrm>
+            <a:off x="548640" y="2468880"/>
+            <a:ext cx="1097280" cy="274320"/>
+          </a:xfrm>
+          <a:prstGeom prst="rect">
+            <a:avLst/>
+          </a:prstGeom>
+          <a:noFill/>
+          <a:ln/>
+        </p:spPr>
+        <p:txBody>
+          <a:bodyPr wrap="square" lIns="0" tIns="0" rIns="0" bIns="0" rtlCol="0" anchor="t"/>
+          <a:lstStyle/>
+          <a:p>
+            <a:pPr indent="0" marL="0">
+              <a:buNone/>
+            </a:pPr>
+            <a:r>
+              <a:rPr lang="en-US" sz="1250" b="1" dirty="0">
                 <a:solidFill>
                   <a:schemeClr val="tx1"/>
                 </a:solidFill>
@@ -2683,104 +2791,65 @@
                 <a:ea typeface="Cambria" pitchFamily="34" charset="-122"/>
                 <a:cs typeface="Cambria" pitchFamily="34" charset="-120"/>
               </a:rPr>
-              <a:t>Zero-shot CLIP</a:t>
-            </a:r>
-            <a:endParaRPr lang="en-US" sz="1400" dirty="0"/>
-          </a:p>
-        </p:txBody>
-      </p:sp>
-      <p:sp>
-        <p:nvSpPr>
-          <p:cNvPr id="6" name="Text 4"/>
-          <p:cNvSpPr txBox="1"/>
-          <p:nvPr/>
-        </p:nvSpPr>
-        <p:spPr>
-          <a:xfrm>
-            <a:off x="566928" y="2011680"/>
-            <a:ext cx="1325880" cy="365760"/>
-          </a:xfrm>
-          <a:prstGeom prst="rect">
-            <a:avLst/>
-          </a:prstGeom>
-          <a:noFill/>
-          <a:ln/>
-        </p:spPr>
-        <p:txBody>
-          <a:bodyPr wrap="square" lIns="0" tIns="0" rIns="0" bIns="0" rtlCol="0" anchor="t"/>
-          <a:lstStyle/>
-          <a:p>
-            <a:pPr indent="0" marL="0">
-              <a:buNone/>
-            </a:pPr>
-            <a:r>
-              <a:rPr lang="en-US" sz="1200" b="1" dirty="0">
-                <a:solidFill>
-                  <a:schemeClr val="accent1"/>
+              <a:t>Crazing</a:t>
+            </a:r>
+            <a:endParaRPr lang="en-US" sz="1250" dirty="0"/>
+          </a:p>
+        </p:txBody>
+      </p:sp>
+      <p:sp>
+        <p:nvSpPr>
+          <p:cNvPr id="6" name="Text 3"/>
+          <p:cNvSpPr txBox="1"/>
+          <p:nvPr/>
+        </p:nvSpPr>
+        <p:spPr>
+          <a:xfrm>
+            <a:off x="548640" y="2788920"/>
+            <a:ext cx="1097280" cy="868680"/>
+          </a:xfrm>
+          <a:prstGeom prst="rect">
+            <a:avLst/>
+          </a:prstGeom>
+          <a:noFill/>
+          <a:ln/>
+        </p:spPr>
+        <p:txBody>
+          <a:bodyPr wrap="square" lIns="0" tIns="0" rIns="0" bIns="0" rtlCol="0" anchor="t"/>
+          <a:lstStyle/>
+          <a:p>
+            <a:pPr indent="0" marL="0">
+              <a:buNone/>
+            </a:pPr>
+            <a:r>
+              <a:rPr lang="en-US" sz="1050" dirty="0">
+                <a:solidFill>
+                  <a:schemeClr val="accent3"/>
                 </a:solidFill>
                 <a:latin typeface="Calibri" pitchFamily="34" charset="0"/>
                 <a:ea typeface="Calibri" pitchFamily="34" charset="-122"/>
                 <a:cs typeface="Calibri" pitchFamily="34" charset="-120"/>
               </a:rPr>
-              <a:t>No training</a:t>
-            </a:r>
-            <a:endParaRPr lang="en-US" sz="1200" dirty="0"/>
-          </a:p>
-        </p:txBody>
-      </p:sp>
-      <p:sp>
-        <p:nvSpPr>
-          <p:cNvPr id="7" name="Text 5"/>
-          <p:cNvSpPr txBox="1"/>
-          <p:nvPr/>
-        </p:nvSpPr>
-        <p:spPr>
-          <a:xfrm>
-            <a:off x="566928" y="2423160"/>
-            <a:ext cx="1325880" cy="640080"/>
-          </a:xfrm>
-          <a:prstGeom prst="rect">
-            <a:avLst/>
-          </a:prstGeom>
-          <a:noFill/>
-          <a:ln/>
-        </p:spPr>
-        <p:txBody>
-          <a:bodyPr wrap="square" lIns="0" tIns="0" rIns="0" bIns="0" rtlCol="0" anchor="t"/>
-          <a:lstStyle/>
-          <a:p>
-            <a:pPr indent="0" marL="0">
-              <a:buNone/>
-            </a:pPr>
-            <a:r>
-              <a:rPr lang="en-US" sz="1100" dirty="0">
-                <a:solidFill>
-                  <a:schemeClr val="tx1"/>
-                </a:solidFill>
-                <a:latin typeface="Calibri" pitchFamily="34" charset="0"/>
-                <a:ea typeface="Calibri" pitchFamily="34" charset="-122"/>
-                <a:cs typeface="Calibri" pitchFamily="34" charset="-120"/>
-              </a:rPr>
-              <a:t>Text prompts only</a:t>
-            </a:r>
-            <a:endParaRPr lang="en-US" sz="1100" dirty="0"/>
-          </a:p>
-        </p:txBody>
-      </p:sp>
-      <p:sp>
-        <p:nvSpPr>
-          <p:cNvPr id="8" name="Shape 6"/>
+              <a:t>Fine network of surface cracks</a:t>
+            </a:r>
+            <a:endParaRPr lang="en-US" sz="1050" dirty="0"/>
+          </a:p>
+        </p:txBody>
+      </p:sp>
+      <p:sp>
+        <p:nvSpPr>
+          <p:cNvPr id="7" name="Shape 4"/>
           <p:cNvSpPr/>
           <p:nvPr/>
         </p:nvSpPr>
         <p:spPr>
           <a:xfrm>
-            <a:off x="2103120" y="1234440"/>
-            <a:ext cx="1536192" cy="1920240"/>
+            <a:off x="1828800" y="1188720"/>
+            <a:ext cx="1280160" cy="2514600"/>
           </a:xfrm>
           <a:prstGeom prst="roundRect">
             <a:avLst>
-              <a:gd name="adj" fmla="val 4762"/>
+              <a:gd name="adj" fmla="val 5714"/>
             </a:avLst>
           </a:prstGeom>
           <a:solidFill>
@@ -2794,57 +2863,56 @@
           </a:ln>
         </p:spPr>
       </p:sp>
-      <p:sp>
-        <p:nvSpPr>
-          <p:cNvPr id="9" name="Shape 7"/>
-          <p:cNvSpPr/>
-          <p:nvPr/>
-        </p:nvSpPr>
-        <p:spPr>
-          <a:xfrm>
-            <a:off x="2103120" y="1234440"/>
-            <a:ext cx="1536192" cy="82296"/>
-          </a:xfrm>
-          <a:prstGeom prst="rect">
-            <a:avLst/>
-          </a:prstGeom>
-          <a:solidFill>
-            <a:schemeClr val="accent4"/>
-          </a:solidFill>
-          <a:ln w="12700">
-            <a:solidFill>
-              <a:schemeClr val="accent4"/>
-            </a:solidFill>
-            <a:prstDash val="solid"/>
-          </a:ln>
-        </p:spPr>
-      </p:sp>
-      <p:sp>
-        <p:nvSpPr>
-          <p:cNvPr id="10" name="Text 8"/>
-          <p:cNvSpPr txBox="1"/>
-          <p:nvPr/>
-        </p:nvSpPr>
-        <p:spPr>
-          <a:xfrm>
-            <a:off x="2212848" y="1417320"/>
-            <a:ext cx="1325880" cy="548640"/>
-          </a:xfrm>
-          <a:prstGeom prst="rect">
-            <a:avLst/>
-          </a:prstGeom>
-          <a:noFill/>
-          <a:ln/>
-        </p:spPr>
-        <p:txBody>
-          <a:bodyPr wrap="square" lIns="0" tIns="0" rIns="0" bIns="0" rtlCol="0" anchor="t"/>
-          <a:lstStyle/>
-          <a:p>
-            <a:pPr indent="0" marL="0">
-              <a:buNone/>
-            </a:pPr>
-            <a:r>
-              <a:rPr lang="en-US" sz="1400" b="1" dirty="0">
+      <p:pic>
+        <p:nvPicPr>
+          <p:cNvPr id="8" name="Image 1" descr="/home/claude/fig/defect_inclusion.png">    </p:cNvPr>
+          <p:cNvPicPr>
+            <a:picLocks noChangeAspect="1"/>
+          </p:cNvPicPr>
+          <p:nvPr/>
+        </p:nvPicPr>
+        <p:blipFill>
+          <a:blip r:embed="rId2"/>
+          <a:stretch>
+            <a:fillRect/>
+          </a:stretch>
+        </p:blipFill>
+        <p:spPr>
+          <a:xfrm>
+            <a:off x="1920240" y="1280160"/>
+            <a:ext cx="1097280" cy="1097280"/>
+          </a:xfrm>
+          <a:prstGeom prst="rect">
+            <a:avLst/>
+          </a:prstGeom>
+        </p:spPr>
+      </p:pic>
+      <p:sp>
+        <p:nvSpPr>
+          <p:cNvPr id="9" name="Text 5"/>
+          <p:cNvSpPr txBox="1"/>
+          <p:nvPr/>
+        </p:nvSpPr>
+        <p:spPr>
+          <a:xfrm>
+            <a:off x="1920240" y="2468880"/>
+            <a:ext cx="1097280" cy="274320"/>
+          </a:xfrm>
+          <a:prstGeom prst="rect">
+            <a:avLst/>
+          </a:prstGeom>
+          <a:noFill/>
+          <a:ln/>
+        </p:spPr>
+        <p:txBody>
+          <a:bodyPr wrap="square" lIns="0" tIns="0" rIns="0" bIns="0" rtlCol="0" anchor="t"/>
+          <a:lstStyle/>
+          <a:p>
+            <a:pPr indent="0" marL="0">
+              <a:buNone/>
+            </a:pPr>
+            <a:r>
+              <a:rPr lang="en-US" sz="1250" b="1" dirty="0">
                 <a:solidFill>
                   <a:schemeClr val="tx1"/>
                 </a:solidFill>
@@ -2852,104 +2920,65 @@
                 <a:ea typeface="Cambria" pitchFamily="34" charset="-122"/>
                 <a:cs typeface="Cambria" pitchFamily="34" charset="-120"/>
               </a:rPr>
-              <a:t>Frozen CLIP + LR</a:t>
-            </a:r>
-            <a:endParaRPr lang="en-US" sz="1400" dirty="0"/>
-          </a:p>
-        </p:txBody>
-      </p:sp>
-      <p:sp>
-        <p:nvSpPr>
-          <p:cNvPr id="11" name="Text 9"/>
-          <p:cNvSpPr txBox="1"/>
-          <p:nvPr/>
-        </p:nvSpPr>
-        <p:spPr>
-          <a:xfrm>
-            <a:off x="2212848" y="2011680"/>
-            <a:ext cx="1325880" cy="365760"/>
-          </a:xfrm>
-          <a:prstGeom prst="rect">
-            <a:avLst/>
-          </a:prstGeom>
-          <a:noFill/>
-          <a:ln/>
-        </p:spPr>
-        <p:txBody>
-          <a:bodyPr wrap="square" lIns="0" tIns="0" rIns="0" bIns="0" rtlCol="0" anchor="t"/>
-          <a:lstStyle/>
-          <a:p>
-            <a:pPr indent="0" marL="0">
-              <a:buNone/>
-            </a:pPr>
-            <a:r>
-              <a:rPr lang="en-US" sz="1200" b="1" dirty="0">
-                <a:solidFill>
-                  <a:schemeClr val="accent1"/>
+              <a:t>Inclusion</a:t>
+            </a:r>
+            <a:endParaRPr lang="en-US" sz="1250" dirty="0"/>
+          </a:p>
+        </p:txBody>
+      </p:sp>
+      <p:sp>
+        <p:nvSpPr>
+          <p:cNvPr id="10" name="Text 6"/>
+          <p:cNvSpPr txBox="1"/>
+          <p:nvPr/>
+        </p:nvSpPr>
+        <p:spPr>
+          <a:xfrm>
+            <a:off x="1920240" y="2788920"/>
+            <a:ext cx="1097280" cy="868680"/>
+          </a:xfrm>
+          <a:prstGeom prst="rect">
+            <a:avLst/>
+          </a:prstGeom>
+          <a:noFill/>
+          <a:ln/>
+        </p:spPr>
+        <p:txBody>
+          <a:bodyPr wrap="square" lIns="0" tIns="0" rIns="0" bIns="0" rtlCol="0" anchor="t"/>
+          <a:lstStyle/>
+          <a:p>
+            <a:pPr indent="0" marL="0">
+              <a:buNone/>
+            </a:pPr>
+            <a:r>
+              <a:rPr lang="en-US" sz="1050" dirty="0">
+                <a:solidFill>
+                  <a:schemeClr val="accent3"/>
                 </a:solidFill>
                 <a:latin typeface="Calibri" pitchFamily="34" charset="0"/>
                 <a:ea typeface="Calibri" pitchFamily="34" charset="-122"/>
                 <a:cs typeface="Calibri" pitchFamily="34" charset="-120"/>
               </a:rPr>
-              <a:t>3k parameters</a:t>
-            </a:r>
-            <a:endParaRPr lang="en-US" sz="1200" dirty="0"/>
-          </a:p>
-        </p:txBody>
-      </p:sp>
-      <p:sp>
-        <p:nvSpPr>
-          <p:cNvPr id="12" name="Text 10"/>
-          <p:cNvSpPr txBox="1"/>
-          <p:nvPr/>
-        </p:nvSpPr>
-        <p:spPr>
-          <a:xfrm>
-            <a:off x="2212848" y="2423160"/>
-            <a:ext cx="1325880" cy="640080"/>
-          </a:xfrm>
-          <a:prstGeom prst="rect">
-            <a:avLst/>
-          </a:prstGeom>
-          <a:noFill/>
-          <a:ln/>
-        </p:spPr>
-        <p:txBody>
-          <a:bodyPr wrap="square" lIns="0" tIns="0" rIns="0" bIns="0" rtlCol="0" anchor="t"/>
-          <a:lstStyle/>
-          <a:p>
-            <a:pPr indent="0" marL="0">
-              <a:buNone/>
-            </a:pPr>
-            <a:r>
-              <a:rPr lang="en-US" sz="1100" dirty="0">
-                <a:solidFill>
-                  <a:schemeClr val="tx1"/>
-                </a:solidFill>
-                <a:latin typeface="Calibri" pitchFamily="34" charset="0"/>
-                <a:ea typeface="Calibri" pitchFamily="34" charset="-122"/>
-                <a:cs typeface="Calibri" pitchFamily="34" charset="-120"/>
-              </a:rPr>
-              <a:t>Linear classifier on frozen features</a:t>
-            </a:r>
-            <a:endParaRPr lang="en-US" sz="1100" dirty="0"/>
-          </a:p>
-        </p:txBody>
-      </p:sp>
-      <p:sp>
-        <p:nvSpPr>
-          <p:cNvPr id="13" name="Shape 11"/>
+              <a:t>Embedded particles seen as dark streaks</a:t>
+            </a:r>
+            <a:endParaRPr lang="en-US" sz="1050" dirty="0"/>
+          </a:p>
+        </p:txBody>
+      </p:sp>
+      <p:sp>
+        <p:nvSpPr>
+          <p:cNvPr id="11" name="Shape 7"/>
           <p:cNvSpPr/>
           <p:nvPr/>
         </p:nvSpPr>
         <p:spPr>
           <a:xfrm>
-            <a:off x="3749040" y="1234440"/>
-            <a:ext cx="1536192" cy="1920240"/>
+            <a:off x="3200400" y="1188720"/>
+            <a:ext cx="1280160" cy="2514600"/>
           </a:xfrm>
           <a:prstGeom prst="roundRect">
             <a:avLst>
-              <a:gd name="adj" fmla="val 4762"/>
+              <a:gd name="adj" fmla="val 5714"/>
             </a:avLst>
           </a:prstGeom>
           <a:solidFill>
@@ -2963,57 +2992,56 @@
           </a:ln>
         </p:spPr>
       </p:sp>
-      <p:sp>
-        <p:nvSpPr>
-          <p:cNvPr id="14" name="Shape 12"/>
-          <p:cNvSpPr/>
-          <p:nvPr/>
-        </p:nvSpPr>
-        <p:spPr>
-          <a:xfrm>
-            <a:off x="3749040" y="1234440"/>
-            <a:ext cx="1536192" cy="82296"/>
-          </a:xfrm>
-          <a:prstGeom prst="rect">
-            <a:avLst/>
-          </a:prstGeom>
-          <a:solidFill>
-            <a:schemeClr val="accent2"/>
-          </a:solidFill>
-          <a:ln w="12700">
-            <a:solidFill>
-              <a:schemeClr val="accent2"/>
-            </a:solidFill>
-            <a:prstDash val="solid"/>
-          </a:ln>
-        </p:spPr>
-      </p:sp>
-      <p:sp>
-        <p:nvSpPr>
-          <p:cNvPr id="15" name="Text 13"/>
-          <p:cNvSpPr txBox="1"/>
-          <p:nvPr/>
-        </p:nvSpPr>
-        <p:spPr>
-          <a:xfrm>
-            <a:off x="3858768" y="1417320"/>
-            <a:ext cx="1325880" cy="548640"/>
-          </a:xfrm>
-          <a:prstGeom prst="rect">
-            <a:avLst/>
-          </a:prstGeom>
-          <a:noFill/>
-          <a:ln/>
-        </p:spPr>
-        <p:txBody>
-          <a:bodyPr wrap="square" lIns="0" tIns="0" rIns="0" bIns="0" rtlCol="0" anchor="t"/>
-          <a:lstStyle/>
-          <a:p>
-            <a:pPr indent="0" marL="0">
-              <a:buNone/>
-            </a:pPr>
-            <a:r>
-              <a:rPr lang="en-US" sz="1400" b="1" dirty="0">
+      <p:pic>
+        <p:nvPicPr>
+          <p:cNvPr id="12" name="Image 2" descr="/home/claude/fig/defect_patches.png">    </p:cNvPr>
+          <p:cNvPicPr>
+            <a:picLocks noChangeAspect="1"/>
+          </p:cNvPicPr>
+          <p:nvPr/>
+        </p:nvPicPr>
+        <p:blipFill>
+          <a:blip r:embed="rId3"/>
+          <a:stretch>
+            <a:fillRect/>
+          </a:stretch>
+        </p:blipFill>
+        <p:spPr>
+          <a:xfrm>
+            <a:off x="3291840" y="1280160"/>
+            <a:ext cx="1097280" cy="1097280"/>
+          </a:xfrm>
+          <a:prstGeom prst="rect">
+            <a:avLst/>
+          </a:prstGeom>
+        </p:spPr>
+      </p:pic>
+      <p:sp>
+        <p:nvSpPr>
+          <p:cNvPr id="13" name="Text 8"/>
+          <p:cNvSpPr txBox="1"/>
+          <p:nvPr/>
+        </p:nvSpPr>
+        <p:spPr>
+          <a:xfrm>
+            <a:off x="3291840" y="2468880"/>
+            <a:ext cx="1097280" cy="274320"/>
+          </a:xfrm>
+          <a:prstGeom prst="rect">
+            <a:avLst/>
+          </a:prstGeom>
+          <a:noFill/>
+          <a:ln/>
+        </p:spPr>
+        <p:txBody>
+          <a:bodyPr wrap="square" lIns="0" tIns="0" rIns="0" bIns="0" rtlCol="0" anchor="t"/>
+          <a:lstStyle/>
+          <a:p>
+            <a:pPr indent="0" marL="0">
+              <a:buNone/>
+            </a:pPr>
+            <a:r>
+              <a:rPr lang="en-US" sz="1250" b="1" dirty="0">
                 <a:solidFill>
                   <a:schemeClr val="tx1"/>
                 </a:solidFill>
@@ -3021,104 +3049,65 @@
                 <a:ea typeface="Cambria" pitchFamily="34" charset="-122"/>
                 <a:cs typeface="Cambria" pitchFamily="34" charset="-120"/>
               </a:rPr>
-              <a:t>Partial fine-tune</a:t>
-            </a:r>
-            <a:endParaRPr lang="en-US" sz="1400" dirty="0"/>
-          </a:p>
-        </p:txBody>
-      </p:sp>
-      <p:sp>
-        <p:nvSpPr>
-          <p:cNvPr id="16" name="Text 14"/>
-          <p:cNvSpPr txBox="1"/>
-          <p:nvPr/>
-        </p:nvSpPr>
-        <p:spPr>
-          <a:xfrm>
-            <a:off x="3858768" y="2011680"/>
-            <a:ext cx="1325880" cy="365760"/>
-          </a:xfrm>
-          <a:prstGeom prst="rect">
-            <a:avLst/>
-          </a:prstGeom>
-          <a:noFill/>
-          <a:ln/>
-        </p:spPr>
-        <p:txBody>
-          <a:bodyPr wrap="square" lIns="0" tIns="0" rIns="0" bIns="0" rtlCol="0" anchor="t"/>
-          <a:lstStyle/>
-          <a:p>
-            <a:pPr indent="0" marL="0">
-              <a:buNone/>
-            </a:pPr>
-            <a:r>
-              <a:rPr lang="en-US" sz="1200" b="1" dirty="0">
-                <a:solidFill>
-                  <a:schemeClr val="accent1"/>
+              <a:t>Patches</a:t>
+            </a:r>
+            <a:endParaRPr lang="en-US" sz="1250" dirty="0"/>
+          </a:p>
+        </p:txBody>
+      </p:sp>
+      <p:sp>
+        <p:nvSpPr>
+          <p:cNvPr id="14" name="Text 9"/>
+          <p:cNvSpPr txBox="1"/>
+          <p:nvPr/>
+        </p:nvSpPr>
+        <p:spPr>
+          <a:xfrm>
+            <a:off x="3291840" y="2788920"/>
+            <a:ext cx="1097280" cy="868680"/>
+          </a:xfrm>
+          <a:prstGeom prst="rect">
+            <a:avLst/>
+          </a:prstGeom>
+          <a:noFill/>
+          <a:ln/>
+        </p:spPr>
+        <p:txBody>
+          <a:bodyPr wrap="square" lIns="0" tIns="0" rIns="0" bIns="0" rtlCol="0" anchor="t"/>
+          <a:lstStyle/>
+          <a:p>
+            <a:pPr indent="0" marL="0">
+              <a:buNone/>
+            </a:pPr>
+            <a:r>
+              <a:rPr lang="en-US" sz="1050" dirty="0">
+                <a:solidFill>
+                  <a:schemeClr val="accent3"/>
                 </a:solidFill>
                 <a:latin typeface="Calibri" pitchFamily="34" charset="0"/>
                 <a:ea typeface="Calibri" pitchFamily="34" charset="-122"/>
                 <a:cs typeface="Calibri" pitchFamily="34" charset="-120"/>
               </a:rPr>
-              <a:t>about 15M parameters</a:t>
-            </a:r>
-            <a:endParaRPr lang="en-US" sz="1200" dirty="0"/>
-          </a:p>
-        </p:txBody>
-      </p:sp>
-      <p:sp>
-        <p:nvSpPr>
-          <p:cNvPr id="17" name="Text 15"/>
-          <p:cNvSpPr txBox="1"/>
-          <p:nvPr/>
-        </p:nvSpPr>
-        <p:spPr>
-          <a:xfrm>
-            <a:off x="3858768" y="2423160"/>
-            <a:ext cx="1325880" cy="640080"/>
-          </a:xfrm>
-          <a:prstGeom prst="rect">
-            <a:avLst/>
-          </a:prstGeom>
-          <a:noFill/>
-          <a:ln/>
-        </p:spPr>
-        <p:txBody>
-          <a:bodyPr wrap="square" lIns="0" tIns="0" rIns="0" bIns="0" rtlCol="0" anchor="t"/>
-          <a:lstStyle/>
-          <a:p>
-            <a:pPr indent="0" marL="0">
-              <a:buNone/>
-            </a:pPr>
-            <a:r>
-              <a:rPr lang="en-US" sz="1100" dirty="0">
-                <a:solidFill>
-                  <a:schemeClr val="tx1"/>
-                </a:solidFill>
-                <a:latin typeface="Calibri" pitchFamily="34" charset="0"/>
-                <a:ea typeface="Calibri" pitchFamily="34" charset="-122"/>
-                <a:cs typeface="Calibri" pitchFamily="34" charset="-120"/>
-              </a:rPr>
-              <a:t>Last 2 of 12 blocks</a:t>
-            </a:r>
-            <a:endParaRPr lang="en-US" sz="1100" dirty="0"/>
-          </a:p>
-        </p:txBody>
-      </p:sp>
-      <p:sp>
-        <p:nvSpPr>
-          <p:cNvPr id="18" name="Shape 16"/>
+              <a:t>Large irregular dark blotches</a:t>
+            </a:r>
+            <a:endParaRPr lang="en-US" sz="1050" dirty="0"/>
+          </a:p>
+        </p:txBody>
+      </p:sp>
+      <p:sp>
+        <p:nvSpPr>
+          <p:cNvPr id="15" name="Shape 10"/>
           <p:cNvSpPr/>
           <p:nvPr/>
         </p:nvSpPr>
         <p:spPr>
           <a:xfrm>
-            <a:off x="5394960" y="1234440"/>
-            <a:ext cx="1536192" cy="1920240"/>
+            <a:off x="4572000" y="1188720"/>
+            <a:ext cx="1280160" cy="2514600"/>
           </a:xfrm>
           <a:prstGeom prst="roundRect">
             <a:avLst>
-              <a:gd name="adj" fmla="val 4762"/>
+              <a:gd name="adj" fmla="val 5714"/>
             </a:avLst>
           </a:prstGeom>
           <a:solidFill>
@@ -3132,57 +3121,56 @@
           </a:ln>
         </p:spPr>
       </p:sp>
-      <p:sp>
-        <p:nvSpPr>
-          <p:cNvPr id="19" name="Shape 17"/>
-          <p:cNvSpPr/>
-          <p:nvPr/>
-        </p:nvSpPr>
-        <p:spPr>
-          <a:xfrm>
-            <a:off x="5394960" y="1234440"/>
-            <a:ext cx="1536192" cy="82296"/>
-          </a:xfrm>
-          <a:prstGeom prst="rect">
-            <a:avLst/>
-          </a:prstGeom>
-          <a:solidFill>
-            <a:schemeClr val="accent1"/>
-          </a:solidFill>
-          <a:ln w="12700">
-            <a:solidFill>
-              <a:schemeClr val="accent1"/>
-            </a:solidFill>
-            <a:prstDash val="solid"/>
-          </a:ln>
-        </p:spPr>
-      </p:sp>
-      <p:sp>
-        <p:nvSpPr>
-          <p:cNvPr id="20" name="Text 18"/>
-          <p:cNvSpPr txBox="1"/>
-          <p:nvPr/>
-        </p:nvSpPr>
-        <p:spPr>
-          <a:xfrm>
-            <a:off x="5504688" y="1417320"/>
-            <a:ext cx="1325880" cy="548640"/>
-          </a:xfrm>
-          <a:prstGeom prst="rect">
-            <a:avLst/>
-          </a:prstGeom>
-          <a:noFill/>
-          <a:ln/>
-        </p:spPr>
-        <p:txBody>
-          <a:bodyPr wrap="square" lIns="0" tIns="0" rIns="0" bIns="0" rtlCol="0" anchor="t"/>
-          <a:lstStyle/>
-          <a:p>
-            <a:pPr indent="0" marL="0">
-              <a:buNone/>
-            </a:pPr>
-            <a:r>
-              <a:rPr lang="en-US" sz="1400" b="1" dirty="0">
+      <p:pic>
+        <p:nvPicPr>
+          <p:cNvPr id="16" name="Image 3" descr="/home/claude/fig/defect_pitted_surface.png">    </p:cNvPr>
+          <p:cNvPicPr>
+            <a:picLocks noChangeAspect="1"/>
+          </p:cNvPicPr>
+          <p:nvPr/>
+        </p:nvPicPr>
+        <p:blipFill>
+          <a:blip r:embed="rId4"/>
+          <a:stretch>
+            <a:fillRect/>
+          </a:stretch>
+        </p:blipFill>
+        <p:spPr>
+          <a:xfrm>
+            <a:off x="4663440" y="1280160"/>
+            <a:ext cx="1097280" cy="1097280"/>
+          </a:xfrm>
+          <a:prstGeom prst="rect">
+            <a:avLst/>
+          </a:prstGeom>
+        </p:spPr>
+      </p:pic>
+      <p:sp>
+        <p:nvSpPr>
+          <p:cNvPr id="17" name="Text 11"/>
+          <p:cNvSpPr txBox="1"/>
+          <p:nvPr/>
+        </p:nvSpPr>
+        <p:spPr>
+          <a:xfrm>
+            <a:off x="4663440" y="2468880"/>
+            <a:ext cx="1097280" cy="274320"/>
+          </a:xfrm>
+          <a:prstGeom prst="rect">
+            <a:avLst/>
+          </a:prstGeom>
+          <a:noFill/>
+          <a:ln/>
+        </p:spPr>
+        <p:txBody>
+          <a:bodyPr wrap="square" lIns="0" tIns="0" rIns="0" bIns="0" rtlCol="0" anchor="t"/>
+          <a:lstStyle/>
+          <a:p>
+            <a:pPr indent="0" marL="0">
+              <a:buNone/>
+            </a:pPr>
+            <a:r>
+              <a:rPr lang="en-US" sz="1250" b="1" dirty="0">
                 <a:solidFill>
                   <a:schemeClr val="tx1"/>
                 </a:solidFill>
@@ -3190,104 +3178,65 @@
                 <a:ea typeface="Cambria" pitchFamily="34" charset="-122"/>
                 <a:cs typeface="Cambria" pitchFamily="34" charset="-120"/>
               </a:rPr>
-              <a:t>Full fine-tune</a:t>
-            </a:r>
-            <a:endParaRPr lang="en-US" sz="1400" dirty="0"/>
-          </a:p>
-        </p:txBody>
-      </p:sp>
-      <p:sp>
-        <p:nvSpPr>
-          <p:cNvPr id="21" name="Text 19"/>
-          <p:cNvSpPr txBox="1"/>
-          <p:nvPr/>
-        </p:nvSpPr>
-        <p:spPr>
-          <a:xfrm>
-            <a:off x="5504688" y="2011680"/>
-            <a:ext cx="1325880" cy="365760"/>
-          </a:xfrm>
-          <a:prstGeom prst="rect">
-            <a:avLst/>
-          </a:prstGeom>
-          <a:noFill/>
-          <a:ln/>
-        </p:spPr>
-        <p:txBody>
-          <a:bodyPr wrap="square" lIns="0" tIns="0" rIns="0" bIns="0" rtlCol="0" anchor="t"/>
-          <a:lstStyle/>
-          <a:p>
-            <a:pPr indent="0" marL="0">
-              <a:buNone/>
-            </a:pPr>
-            <a:r>
-              <a:rPr lang="en-US" sz="1200" b="1" dirty="0">
-                <a:solidFill>
-                  <a:schemeClr val="accent1"/>
+              <a:t>Pitted surface</a:t>
+            </a:r>
+            <a:endParaRPr lang="en-US" sz="1250" dirty="0"/>
+          </a:p>
+        </p:txBody>
+      </p:sp>
+      <p:sp>
+        <p:nvSpPr>
+          <p:cNvPr id="18" name="Text 12"/>
+          <p:cNvSpPr txBox="1"/>
+          <p:nvPr/>
+        </p:nvSpPr>
+        <p:spPr>
+          <a:xfrm>
+            <a:off x="4663440" y="2788920"/>
+            <a:ext cx="1097280" cy="868680"/>
+          </a:xfrm>
+          <a:prstGeom prst="rect">
+            <a:avLst/>
+          </a:prstGeom>
+          <a:noFill/>
+          <a:ln/>
+        </p:spPr>
+        <p:txBody>
+          <a:bodyPr wrap="square" lIns="0" tIns="0" rIns="0" bIns="0" rtlCol="0" anchor="t"/>
+          <a:lstStyle/>
+          <a:p>
+            <a:pPr indent="0" marL="0">
+              <a:buNone/>
+            </a:pPr>
+            <a:r>
+              <a:rPr lang="en-US" sz="1050" dirty="0">
+                <a:solidFill>
+                  <a:schemeClr val="accent3"/>
                 </a:solidFill>
                 <a:latin typeface="Calibri" pitchFamily="34" charset="0"/>
                 <a:ea typeface="Calibri" pitchFamily="34" charset="-122"/>
                 <a:cs typeface="Calibri" pitchFamily="34" charset="-120"/>
               </a:rPr>
-              <a:t>about 86M parameters</a:t>
-            </a:r>
-            <a:endParaRPr lang="en-US" sz="1200" dirty="0"/>
-          </a:p>
-        </p:txBody>
-      </p:sp>
-      <p:sp>
-        <p:nvSpPr>
-          <p:cNvPr id="22" name="Text 20"/>
-          <p:cNvSpPr txBox="1"/>
-          <p:nvPr/>
-        </p:nvSpPr>
-        <p:spPr>
-          <a:xfrm>
-            <a:off x="5504688" y="2423160"/>
-            <a:ext cx="1325880" cy="640080"/>
-          </a:xfrm>
-          <a:prstGeom prst="rect">
-            <a:avLst/>
-          </a:prstGeom>
-          <a:noFill/>
-          <a:ln/>
-        </p:spPr>
-        <p:txBody>
-          <a:bodyPr wrap="square" lIns="0" tIns="0" rIns="0" bIns="0" rtlCol="0" anchor="t"/>
-          <a:lstStyle/>
-          <a:p>
-            <a:pPr indent="0" marL="0">
-              <a:buNone/>
-            </a:pPr>
-            <a:r>
-              <a:rPr lang="en-US" sz="1100" dirty="0">
-                <a:solidFill>
-                  <a:schemeClr val="tx1"/>
-                </a:solidFill>
-                <a:latin typeface="Calibri" pitchFamily="34" charset="0"/>
-                <a:ea typeface="Calibri" pitchFamily="34" charset="-122"/>
-                <a:cs typeface="Calibri" pitchFamily="34" charset="-120"/>
-              </a:rPr>
-              <a:t>CLIP ViT-B/16, all weights</a:t>
-            </a:r>
-            <a:endParaRPr lang="en-US" sz="1100" dirty="0"/>
-          </a:p>
-        </p:txBody>
-      </p:sp>
-      <p:sp>
-        <p:nvSpPr>
-          <p:cNvPr id="23" name="Shape 21"/>
+              <a:t>Many small pits across the surface</a:t>
+            </a:r>
+            <a:endParaRPr lang="en-US" sz="1050" dirty="0"/>
+          </a:p>
+        </p:txBody>
+      </p:sp>
+      <p:sp>
+        <p:nvSpPr>
+          <p:cNvPr id="19" name="Shape 13"/>
           <p:cNvSpPr/>
           <p:nvPr/>
         </p:nvSpPr>
         <p:spPr>
           <a:xfrm>
-            <a:off x="7040880" y="1234440"/>
-            <a:ext cx="1536192" cy="1920240"/>
+            <a:off x="5943600" y="1188720"/>
+            <a:ext cx="1280160" cy="2514600"/>
           </a:xfrm>
           <a:prstGeom prst="roundRect">
             <a:avLst>
-              <a:gd name="adj" fmla="val 4762"/>
+              <a:gd name="adj" fmla="val 5714"/>
             </a:avLst>
           </a:prstGeom>
           <a:solidFill>
@@ -3301,57 +3250,185 @@
           </a:ln>
         </p:spPr>
       </p:sp>
-      <p:sp>
-        <p:nvSpPr>
-          <p:cNvPr id="24" name="Shape 22"/>
+      <p:pic>
+        <p:nvPicPr>
+          <p:cNvPr id="20" name="Image 4" descr="/home/claude/fig/defect_rolled_in_scale.png">    </p:cNvPr>
+          <p:cNvPicPr>
+            <a:picLocks noChangeAspect="1"/>
+          </p:cNvPicPr>
+          <p:nvPr/>
+        </p:nvPicPr>
+        <p:blipFill>
+          <a:blip r:embed="rId5"/>
+          <a:stretch>
+            <a:fillRect/>
+          </a:stretch>
+        </p:blipFill>
+        <p:spPr>
+          <a:xfrm>
+            <a:off x="6035040" y="1280160"/>
+            <a:ext cx="1097280" cy="1097280"/>
+          </a:xfrm>
+          <a:prstGeom prst="rect">
+            <a:avLst/>
+          </a:prstGeom>
+        </p:spPr>
+      </p:pic>
+      <p:sp>
+        <p:nvSpPr>
+          <p:cNvPr id="21" name="Text 14"/>
+          <p:cNvSpPr txBox="1"/>
+          <p:nvPr/>
+        </p:nvSpPr>
+        <p:spPr>
+          <a:xfrm>
+            <a:off x="6035040" y="2468880"/>
+            <a:ext cx="1097280" cy="274320"/>
+          </a:xfrm>
+          <a:prstGeom prst="rect">
+            <a:avLst/>
+          </a:prstGeom>
+          <a:noFill/>
+          <a:ln/>
+        </p:spPr>
+        <p:txBody>
+          <a:bodyPr wrap="square" lIns="0" tIns="0" rIns="0" bIns="0" rtlCol="0" anchor="t"/>
+          <a:lstStyle/>
+          <a:p>
+            <a:pPr indent="0" marL="0">
+              <a:buNone/>
+            </a:pPr>
+            <a:r>
+              <a:rPr lang="en-US" sz="1250" b="1" dirty="0">
+                <a:solidFill>
+                  <a:schemeClr val="tx1"/>
+                </a:solidFill>
+                <a:latin typeface="Cambria" pitchFamily="34" charset="0"/>
+                <a:ea typeface="Cambria" pitchFamily="34" charset="-122"/>
+                <a:cs typeface="Cambria" pitchFamily="34" charset="-120"/>
+              </a:rPr>
+              <a:t>Rolled-in scale</a:t>
+            </a:r>
+            <a:endParaRPr lang="en-US" sz="1250" dirty="0"/>
+          </a:p>
+        </p:txBody>
+      </p:sp>
+      <p:sp>
+        <p:nvSpPr>
+          <p:cNvPr id="22" name="Text 15"/>
+          <p:cNvSpPr txBox="1"/>
+          <p:nvPr/>
+        </p:nvSpPr>
+        <p:spPr>
+          <a:xfrm>
+            <a:off x="6035040" y="2788920"/>
+            <a:ext cx="1097280" cy="868680"/>
+          </a:xfrm>
+          <a:prstGeom prst="rect">
+            <a:avLst/>
+          </a:prstGeom>
+          <a:noFill/>
+          <a:ln/>
+        </p:spPr>
+        <p:txBody>
+          <a:bodyPr wrap="square" lIns="0" tIns="0" rIns="0" bIns="0" rtlCol="0" anchor="t"/>
+          <a:lstStyle/>
+          <a:p>
+            <a:pPr indent="0" marL="0">
+              <a:buNone/>
+            </a:pPr>
+            <a:r>
+              <a:rPr lang="en-US" sz="1050" dirty="0">
+                <a:solidFill>
+                  <a:schemeClr val="accent3"/>
+                </a:solidFill>
+                <a:latin typeface="Calibri" pitchFamily="34" charset="0"/>
+                <a:ea typeface="Calibri" pitchFamily="34" charset="-122"/>
+                <a:cs typeface="Calibri" pitchFamily="34" charset="-120"/>
+              </a:rPr>
+              <a:t>Scale pressed into the steel as small marks</a:t>
+            </a:r>
+            <a:endParaRPr lang="en-US" sz="1050" dirty="0"/>
+          </a:p>
+        </p:txBody>
+      </p:sp>
+      <p:sp>
+        <p:nvSpPr>
+          <p:cNvPr id="23" name="Shape 16"/>
           <p:cNvSpPr/>
           <p:nvPr/>
         </p:nvSpPr>
         <p:spPr>
           <a:xfrm>
-            <a:off x="7040880" y="1234440"/>
-            <a:ext cx="1536192" cy="82296"/>
-          </a:xfrm>
-          <a:prstGeom prst="rect">
-            <a:avLst/>
+            <a:off x="7315200" y="1188720"/>
+            <a:ext cx="1280160" cy="2514600"/>
+          </a:xfrm>
+          <a:prstGeom prst="roundRect">
+            <a:avLst>
+              <a:gd name="adj" fmla="val 5714"/>
+            </a:avLst>
           </a:prstGeom>
           <a:solidFill>
-            <a:schemeClr val="accent5"/>
+            <a:schemeClr val="bg2"/>
           </a:solidFill>
           <a:ln w="12700">
             <a:solidFill>
-              <a:schemeClr val="accent5"/>
+              <a:schemeClr val="bg2"/>
             </a:solidFill>
             <a:prstDash val="solid"/>
           </a:ln>
         </p:spPr>
       </p:sp>
-      <p:sp>
-        <p:nvSpPr>
-          <p:cNvPr id="25" name="Text 23"/>
-          <p:cNvSpPr txBox="1"/>
-          <p:nvPr/>
-        </p:nvSpPr>
-        <p:spPr>
-          <a:xfrm>
-            <a:off x="7150608" y="1417320"/>
-            <a:ext cx="1325880" cy="548640"/>
-          </a:xfrm>
-          <a:prstGeom prst="rect">
-            <a:avLst/>
-          </a:prstGeom>
-          <a:noFill/>
-          <a:ln/>
-        </p:spPr>
-        <p:txBody>
-          <a:bodyPr wrap="square" lIns="0" tIns="0" rIns="0" bIns="0" rtlCol="0" anchor="t"/>
-          <a:lstStyle/>
-          <a:p>
-            <a:pPr indent="0" marL="0">
-              <a:buNone/>
-            </a:pPr>
-            <a:r>
-              <a:rPr lang="en-US" sz="1400" b="1" dirty="0">
+      <p:pic>
+        <p:nvPicPr>
+          <p:cNvPr id="24" name="Image 5" descr="/home/claude/fig/defect_scratches.png">    </p:cNvPr>
+          <p:cNvPicPr>
+            <a:picLocks noChangeAspect="1"/>
+          </p:cNvPicPr>
+          <p:nvPr/>
+        </p:nvPicPr>
+        <p:blipFill>
+          <a:blip r:embed="rId6"/>
+          <a:stretch>
+            <a:fillRect/>
+          </a:stretch>
+        </p:blipFill>
+        <p:spPr>
+          <a:xfrm>
+            <a:off x="7406640" y="1280160"/>
+            <a:ext cx="1097280" cy="1097280"/>
+          </a:xfrm>
+          <a:prstGeom prst="rect">
+            <a:avLst/>
+          </a:prstGeom>
+        </p:spPr>
+      </p:pic>
+      <p:sp>
+        <p:nvSpPr>
+          <p:cNvPr id="25" name="Text 17"/>
+          <p:cNvSpPr txBox="1"/>
+          <p:nvPr/>
+        </p:nvSpPr>
+        <p:spPr>
+          <a:xfrm>
+            <a:off x="7406640" y="2468880"/>
+            <a:ext cx="1097280" cy="274320"/>
+          </a:xfrm>
+          <a:prstGeom prst="rect">
+            <a:avLst/>
+          </a:prstGeom>
+          <a:noFill/>
+          <a:ln/>
+        </p:spPr>
+        <p:txBody>
+          <a:bodyPr wrap="square" lIns="0" tIns="0" rIns="0" bIns="0" rtlCol="0" anchor="t"/>
+          <a:lstStyle/>
+          <a:p>
+            <a:pPr indent="0" marL="0">
+              <a:buNone/>
+            </a:pPr>
+            <a:r>
+              <a:rPr lang="en-US" sz="1250" b="1" dirty="0">
                 <a:solidFill>
                   <a:schemeClr val="tx1"/>
                 </a:solidFill>
@@ -3359,183 +3436,144 @@
                 <a:ea typeface="Cambria" pitchFamily="34" charset="-122"/>
                 <a:cs typeface="Cambria" pitchFamily="34" charset="-120"/>
               </a:rPr>
-              <a:t>ImageNet ViT</a:t>
-            </a:r>
-            <a:endParaRPr lang="en-US" sz="1400" dirty="0"/>
-          </a:p>
-        </p:txBody>
-      </p:sp>
-      <p:sp>
-        <p:nvSpPr>
-          <p:cNvPr id="26" name="Text 24"/>
-          <p:cNvSpPr txBox="1"/>
-          <p:nvPr/>
-        </p:nvSpPr>
-        <p:spPr>
-          <a:xfrm>
-            <a:off x="7150608" y="2011680"/>
-            <a:ext cx="1325880" cy="365760"/>
-          </a:xfrm>
-          <a:prstGeom prst="rect">
-            <a:avLst/>
-          </a:prstGeom>
-          <a:noFill/>
-          <a:ln/>
-        </p:spPr>
-        <p:txBody>
-          <a:bodyPr wrap="square" lIns="0" tIns="0" rIns="0" bIns="0" rtlCol="0" anchor="t"/>
-          <a:lstStyle/>
-          <a:p>
-            <a:pPr indent="0" marL="0">
-              <a:buNone/>
-            </a:pPr>
-            <a:r>
-              <a:rPr lang="en-US" sz="1200" b="1" dirty="0">
-                <a:solidFill>
-                  <a:schemeClr val="accent1"/>
+              <a:t>Scratches</a:t>
+            </a:r>
+            <a:endParaRPr lang="en-US" sz="1250" dirty="0"/>
+          </a:p>
+        </p:txBody>
+      </p:sp>
+      <p:sp>
+        <p:nvSpPr>
+          <p:cNvPr id="26" name="Text 18"/>
+          <p:cNvSpPr txBox="1"/>
+          <p:nvPr/>
+        </p:nvSpPr>
+        <p:spPr>
+          <a:xfrm>
+            <a:off x="7406640" y="2788920"/>
+            <a:ext cx="1097280" cy="868680"/>
+          </a:xfrm>
+          <a:prstGeom prst="rect">
+            <a:avLst/>
+          </a:prstGeom>
+          <a:noFill/>
+          <a:ln/>
+        </p:spPr>
+        <p:txBody>
+          <a:bodyPr wrap="square" lIns="0" tIns="0" rIns="0" bIns="0" rtlCol="0" anchor="t"/>
+          <a:lstStyle/>
+          <a:p>
+            <a:pPr indent="0" marL="0">
+              <a:buNone/>
+            </a:pPr>
+            <a:r>
+              <a:rPr lang="en-US" sz="1050" dirty="0">
+                <a:solidFill>
+                  <a:schemeClr val="accent3"/>
                 </a:solidFill>
                 <a:latin typeface="Calibri" pitchFamily="34" charset="0"/>
                 <a:ea typeface="Calibri" pitchFamily="34" charset="-122"/>
                 <a:cs typeface="Calibri" pitchFamily="34" charset="-120"/>
               </a:rPr>
-              <a:t>about 86M parameters</a:t>
-            </a:r>
-            <a:endParaRPr lang="en-US" sz="1200" dirty="0"/>
-          </a:p>
-        </p:txBody>
-      </p:sp>
-      <p:sp>
-        <p:nvSpPr>
-          <p:cNvPr id="27" name="Text 25"/>
-          <p:cNvSpPr txBox="1"/>
-          <p:nvPr/>
-        </p:nvSpPr>
-        <p:spPr>
-          <a:xfrm>
-            <a:off x="7150608" y="2423160"/>
-            <a:ext cx="1325880" cy="640080"/>
-          </a:xfrm>
-          <a:prstGeom prst="rect">
-            <a:avLst/>
-          </a:prstGeom>
-          <a:noFill/>
-          <a:ln/>
-        </p:spPr>
-        <p:txBody>
-          <a:bodyPr wrap="square" lIns="0" tIns="0" rIns="0" bIns="0" rtlCol="0" anchor="t"/>
-          <a:lstStyle/>
-          <a:p>
-            <a:pPr indent="0" marL="0">
-              <a:buNone/>
-            </a:pPr>
-            <a:r>
-              <a:rPr lang="en-US" sz="1100" dirty="0">
-                <a:solidFill>
-                  <a:schemeClr val="tx1"/>
+              <a:t>Thin bright lines along the strip</a:t>
+            </a:r>
+            <a:endParaRPr lang="en-US" sz="1050" dirty="0"/>
+          </a:p>
+        </p:txBody>
+      </p:sp>
+      <p:sp>
+        <p:nvSpPr>
+          <p:cNvPr id="27" name="Text 19"/>
+          <p:cNvSpPr txBox="1"/>
+          <p:nvPr/>
+        </p:nvSpPr>
+        <p:spPr>
+          <a:xfrm>
+            <a:off x="457200" y="3886200"/>
+            <a:ext cx="8229600" cy="822960"/>
+          </a:xfrm>
+          <a:prstGeom prst="rect">
+            <a:avLst/>
+          </a:prstGeom>
+          <a:noFill/>
+          <a:ln/>
+        </p:spPr>
+        <p:txBody>
+          <a:bodyPr wrap="square" lIns="0" tIns="0" rIns="0" bIns="0" rtlCol="0" anchor="t"/>
+          <a:lstStyle/>
+          <a:p>
+            <a:pPr indent="0" marL="0">
+              <a:spcAft>
+                <a:spcPts val="400"/>
+              </a:spcAft>
+              <a:buNone/>
+            </a:pPr>
+            <a:r>
+              <a:rPr lang="en-US" sz="1250" b="1" dirty="0">
+                <a:solidFill>
+                  <a:schemeClr val="accent1"/>
                 </a:solidFill>
                 <a:latin typeface="Calibri" pitchFamily="34" charset="0"/>
                 <a:ea typeface="Calibri" pitchFamily="34" charset="-122"/>
                 <a:cs typeface="Calibri" pitchFamily="34" charset="-120"/>
               </a:rPr>
-              <a:t>Reference, other pretraining</a:t>
-            </a:r>
-            <a:endParaRPr lang="en-US" sz="1100" dirty="0"/>
-          </a:p>
-        </p:txBody>
-      </p:sp>
-      <p:sp>
-        <p:nvSpPr>
-          <p:cNvPr id="28" name="Text 26"/>
-          <p:cNvSpPr txBox="1"/>
-          <p:nvPr/>
-        </p:nvSpPr>
-        <p:spPr>
-          <a:xfrm>
-            <a:off x="457200" y="3429000"/>
-            <a:ext cx="8229600" cy="1097280"/>
-          </a:xfrm>
-          <a:prstGeom prst="rect">
-            <a:avLst/>
-          </a:prstGeom>
-          <a:noFill/>
-          <a:ln/>
-        </p:spPr>
-        <p:txBody>
-          <a:bodyPr wrap="square" lIns="0" tIns="0" rIns="0" bIns="0" rtlCol="0" anchor="t"/>
-          <a:lstStyle/>
-          <a:p>
+              <a:t>Task: </a:t>
+            </a:r>
             <a:pPr indent="0" marL="0">
               <a:spcAft>
-                <a:spcPts val="600"/>
+                <a:spcPts val="400"/>
               </a:spcAft>
               <a:buNone/>
             </a:pPr>
             <a:r>
-              <a:rPr lang="en-US" sz="1400" b="1" dirty="0">
-                <a:solidFill>
-                  <a:schemeClr val="accent1"/>
+              <a:rPr lang="en-US" sz="1250" dirty="0">
+                <a:solidFill>
+                  <a:schemeClr val="tx1"/>
                 </a:solidFill>
                 <a:latin typeface="Calibri" pitchFamily="34" charset="0"/>
                 <a:ea typeface="Calibri" pitchFamily="34" charset="-122"/>
                 <a:cs typeface="Calibri" pitchFamily="34" charset="-120"/>
               </a:rPr>
-              <a:t>Measured: </a:t>
-            </a:r>
+              <a:t>given one 200 x 200 grayscale image, name its defect. A label is that defect name; the dataset has 1,800 labelled images.</a:t>
+            </a:r>
+            <a:endParaRPr lang="en-US" sz="1250" dirty="0"/>
+          </a:p>
+          <a:p>
             <a:pPr indent="0" marL="0">
               <a:spcAft>
-                <a:spcPts val="600"/>
+                <a:spcPts val="400"/>
               </a:spcAft>
               <a:buNone/>
             </a:pPr>
             <a:r>
-              <a:rPr lang="en-US" sz="1400" dirty="0">
-                <a:solidFill>
-                  <a:schemeClr val="tx1"/>
+              <a:rPr lang="en-US" sz="1250" b="1" dirty="0">
+                <a:solidFill>
+                  <a:schemeClr val="accent1"/>
                 </a:solidFill>
                 <a:latin typeface="Calibri" pitchFamily="34" charset="0"/>
                 <a:ea typeface="Calibri" pitchFamily="34" charset="-122"/>
                 <a:cs typeface="Calibri" pitchFamily="34" charset="-120"/>
               </a:rPr>
-              <a:t>accuracy, log-loss, calibration error, confident mistakes, rare-defect recall, unseen-defect AUROC, blur and noise robustness.</a:t>
-            </a:r>
-            <a:endParaRPr lang="en-US" sz="1400" dirty="0"/>
-          </a:p>
-          <a:p>
+              <a:t>Hardest at 1 label: </a:t>
+            </a:r>
             <a:pPr indent="0" marL="0">
               <a:spcAft>
-                <a:spcPts val="600"/>
+                <a:spcPts val="400"/>
               </a:spcAft>
               <a:buNone/>
             </a:pPr>
             <a:r>
-              <a:rPr lang="en-US" sz="1400" b="1" dirty="0">
-                <a:solidFill>
-                  <a:schemeClr val="accent1"/>
+              <a:rPr lang="en-US" sz="1250" dirty="0">
+                <a:solidFill>
+                  <a:schemeClr val="tx1"/>
                 </a:solidFill>
                 <a:latin typeface="Calibri" pitchFamily="34" charset="0"/>
                 <a:ea typeface="Calibri" pitchFamily="34" charset="-122"/>
                 <a:cs typeface="Calibri" pitchFamily="34" charset="-120"/>
               </a:rPr>
-              <a:t>Compared: </a:t>
-            </a:r>
-            <a:pPr indent="0" marL="0">
-              <a:spcAft>
-                <a:spcPts val="600"/>
-              </a:spcAft>
-              <a:buNone/>
-            </a:pPr>
-            <a:r>
-              <a:rPr lang="en-US" sz="1400" dirty="0">
-                <a:solidFill>
-                  <a:schemeClr val="tx1"/>
-                </a:solidFill>
-                <a:latin typeface="Calibri" pitchFamily="34" charset="0"/>
-                <a:ea typeface="Calibri" pitchFamily="34" charset="-122"/>
-                <a:cs typeface="Calibri" pitchFamily="34" charset="-120"/>
-              </a:rPr>
-              <a:t>paired differences with 95% intervals across folds; frozen baseline also tuned fairly on validation images.</a:t>
-            </a:r>
-            <a:endParaRPr lang="en-US" sz="1400" dirty="0"/>
+              <a:t>scratches, pitting and inclusion (recall 0.66, 0.80, 0.85 for the full fine-tuned model); the other three exceed 0.95.</a:t>
+            </a:r>
+            <a:endParaRPr lang="en-US" sz="1250" dirty="0"/>
           </a:p>
         </p:txBody>
       </p:sp>
@@ -3641,50 +3679,26 @@
                   <a:srgbClr val="1F2A33"/>
                 </a:solidFill>
               </a:rPr>
-              <a:t>Fine-tuning wins with few labels, and the gap closes by about 50</a:t>
+              <a:t>Five ways to use a pretrained transformer, compared on identical splits</a:t>
             </a:r>
             <a:endParaRPr lang="en-US" sz="2400" dirty="0"/>
           </a:p>
         </p:txBody>
       </p:sp>
-      <p:pic>
-        <p:nvPicPr>
-          <p:cNvPr id="3" name="Image 0" descr="/home/claude/fig/fig1_learning_curves.png">    </p:cNvPr>
-          <p:cNvPicPr>
-            <a:picLocks noChangeAspect="1"/>
-          </p:cNvPicPr>
-          <p:nvPr/>
-        </p:nvPicPr>
-        <p:blipFill>
-          <a:blip r:embed="rId1"/>
-          <a:stretch>
-            <a:fillRect/>
-          </a:stretch>
-        </p:blipFill>
-        <p:spPr>
-          <a:xfrm>
-            <a:off x="365760" y="1188720"/>
-            <a:ext cx="5669280" cy="2514600"/>
-          </a:xfrm>
-          <a:prstGeom prst="rect">
-            <a:avLst/>
-          </a:prstGeom>
-        </p:spPr>
-      </p:pic>
-      <p:sp>
-        <p:nvSpPr>
-          <p:cNvPr id="4" name="Shape 1"/>
+      <p:sp>
+        <p:nvSpPr>
+          <p:cNvPr id="3" name="Shape 1"/>
           <p:cNvSpPr/>
           <p:nvPr/>
         </p:nvSpPr>
         <p:spPr>
           <a:xfrm>
-            <a:off x="6217920" y="1188720"/>
-            <a:ext cx="2560320" cy="960120"/>
+            <a:off x="457200" y="1234440"/>
+            <a:ext cx="1536192" cy="2514600"/>
           </a:xfrm>
           <a:prstGeom prst="roundRect">
             <a:avLst>
-              <a:gd name="adj" fmla="val 7619"/>
+              <a:gd name="adj" fmla="val 4762"/>
             </a:avLst>
           </a:prstGeom>
           <a:solidFill>
@@ -3700,77 +3714,141 @@
       </p:sp>
       <p:sp>
         <p:nvSpPr>
-          <p:cNvPr id="5" name="Text 2"/>
-          <p:cNvSpPr txBox="1"/>
-          <p:nvPr/>
-        </p:nvSpPr>
-        <p:spPr>
-          <a:xfrm>
-            <a:off x="6355080" y="1261872"/>
-            <a:ext cx="2286000" cy="457200"/>
-          </a:xfrm>
-          <a:prstGeom prst="rect">
-            <a:avLst/>
-          </a:prstGeom>
-          <a:noFill/>
-          <a:ln/>
-        </p:spPr>
-        <p:txBody>
-          <a:bodyPr wrap="square" lIns="0" tIns="0" rIns="0" bIns="0" rtlCol="0" anchor="t"/>
-          <a:lstStyle/>
-          <a:p>
-            <a:pPr indent="0" marL="0">
-              <a:buNone/>
-            </a:pPr>
-            <a:r>
-              <a:rPr lang="en-US" sz="2400" b="1" dirty="0">
-                <a:solidFill>
-                  <a:schemeClr val="accent1"/>
+          <p:cNvPr id="4" name="Shape 2"/>
+          <p:cNvSpPr/>
+          <p:nvPr/>
+        </p:nvSpPr>
+        <p:spPr>
+          <a:xfrm>
+            <a:off x="457200" y="1234440"/>
+            <a:ext cx="1536192" cy="82296"/>
+          </a:xfrm>
+          <a:prstGeom prst="rect">
+            <a:avLst/>
+          </a:prstGeom>
+          <a:solidFill>
+            <a:schemeClr val="accent3"/>
+          </a:solidFill>
+          <a:ln w="12700">
+            <a:solidFill>
+              <a:schemeClr val="accent3"/>
+            </a:solidFill>
+            <a:prstDash val="solid"/>
+          </a:ln>
+        </p:spPr>
+      </p:sp>
+      <p:sp>
+        <p:nvSpPr>
+          <p:cNvPr id="5" name="Text 3"/>
+          <p:cNvSpPr txBox="1"/>
+          <p:nvPr/>
+        </p:nvSpPr>
+        <p:spPr>
+          <a:xfrm>
+            <a:off x="566928" y="1417320"/>
+            <a:ext cx="1325880" cy="548640"/>
+          </a:xfrm>
+          <a:prstGeom prst="rect">
+            <a:avLst/>
+          </a:prstGeom>
+          <a:noFill/>
+          <a:ln/>
+        </p:spPr>
+        <p:txBody>
+          <a:bodyPr wrap="square" lIns="0" tIns="0" rIns="0" bIns="0" rtlCol="0" anchor="t"/>
+          <a:lstStyle/>
+          <a:p>
+            <a:pPr indent="0" marL="0">
+              <a:buNone/>
+            </a:pPr>
+            <a:r>
+              <a:rPr lang="en-US" sz="1400" b="1" dirty="0">
+                <a:solidFill>
+                  <a:schemeClr val="tx1"/>
                 </a:solidFill>
                 <a:latin typeface="Cambria" pitchFamily="34" charset="0"/>
                 <a:ea typeface="Cambria" pitchFamily="34" charset="-122"/>
                 <a:cs typeface="Cambria" pitchFamily="34" charset="-120"/>
               </a:rPr>
-              <a:t>3 labels</a:t>
-            </a:r>
-            <a:endParaRPr lang="en-US" sz="2400" dirty="0"/>
-          </a:p>
-        </p:txBody>
-      </p:sp>
-      <p:sp>
-        <p:nvSpPr>
-          <p:cNvPr id="6" name="Text 3"/>
-          <p:cNvSpPr txBox="1"/>
-          <p:nvPr/>
-        </p:nvSpPr>
-        <p:spPr>
-          <a:xfrm>
-            <a:off x="6355080" y="1719072"/>
-            <a:ext cx="2286000" cy="393192"/>
-          </a:xfrm>
-          <a:prstGeom prst="rect">
-            <a:avLst/>
-          </a:prstGeom>
-          <a:noFill/>
-          <a:ln/>
-        </p:spPr>
-        <p:txBody>
-          <a:bodyPr wrap="square" lIns="0" tIns="0" rIns="0" bIns="0" rtlCol="0" anchor="t"/>
-          <a:lstStyle/>
-          <a:p>
-            <a:pPr indent="0" marL="0">
-              <a:buNone/>
-            </a:pPr>
-            <a:r>
-              <a:rPr lang="en-US" sz="1100" dirty="0">
-                <a:solidFill>
-                  <a:schemeClr val="tx1"/>
+              <a:t>Zero-shot CLIP</a:t>
+            </a:r>
+            <a:endParaRPr lang="en-US" sz="1400" dirty="0"/>
+          </a:p>
+        </p:txBody>
+      </p:sp>
+      <p:sp>
+        <p:nvSpPr>
+          <p:cNvPr id="6" name="Text 4"/>
+          <p:cNvSpPr txBox="1"/>
+          <p:nvPr/>
+        </p:nvSpPr>
+        <p:spPr>
+          <a:xfrm>
+            <a:off x="566928" y="2011680"/>
+            <a:ext cx="1325880" cy="365760"/>
+          </a:xfrm>
+          <a:prstGeom prst="rect">
+            <a:avLst/>
+          </a:prstGeom>
+          <a:noFill/>
+          <a:ln/>
+        </p:spPr>
+        <p:txBody>
+          <a:bodyPr wrap="square" lIns="0" tIns="0" rIns="0" bIns="0" rtlCol="0" anchor="t"/>
+          <a:lstStyle/>
+          <a:p>
+            <a:pPr indent="0" marL="0">
+              <a:buNone/>
+            </a:pPr>
+            <a:r>
+              <a:rPr lang="en-US" sz="1200" b="1" dirty="0">
+                <a:solidFill>
+                  <a:schemeClr val="accent1"/>
                 </a:solidFill>
                 <a:latin typeface="Calibri" pitchFamily="34" charset="0"/>
                 <a:ea typeface="Calibri" pitchFamily="34" charset="-122"/>
                 <a:cs typeface="Calibri" pitchFamily="34" charset="-120"/>
               </a:rPr>
-              <a:t>per class: full fine-tune reaches 95% (tuned frozen: 10)</a:t>
+              <a:t>No training</a:t>
+            </a:r>
+            <a:endParaRPr lang="en-US" sz="1200" dirty="0"/>
+          </a:p>
+        </p:txBody>
+      </p:sp>
+      <p:sp>
+        <p:nvSpPr>
+          <p:cNvPr id="7" name="Text 5"/>
+          <p:cNvSpPr txBox="1"/>
+          <p:nvPr/>
+        </p:nvSpPr>
+        <p:spPr>
+          <a:xfrm>
+            <a:off x="566928" y="2560320"/>
+            <a:ext cx="1325880" cy="502920"/>
+          </a:xfrm>
+          <a:prstGeom prst="rect">
+            <a:avLst/>
+          </a:prstGeom>
+          <a:noFill/>
+          <a:ln/>
+        </p:spPr>
+        <p:txBody>
+          <a:bodyPr wrap="square" lIns="0" tIns="0" rIns="0" bIns="0" rtlCol="0" anchor="t"/>
+          <a:lstStyle/>
+          <a:p>
+            <a:pPr indent="0" marL="0">
+              <a:buNone/>
+            </a:pPr>
+            <a:r>
+              <a:rPr lang="en-US" sz="1100" dirty="0">
+                <a:solidFill>
+                  <a:schemeClr val="tx1"/>
+                </a:solidFill>
+                <a:latin typeface="Calibri" pitchFamily="34" charset="0"/>
+                <a:ea typeface="Calibri" pitchFamily="34" charset="-122"/>
+                <a:cs typeface="Calibri" pitchFamily="34" charset="-120"/>
+              </a:rPr>
+              <a:t>Text prompts only</a:t>
             </a:r>
             <a:endParaRPr lang="en-US" sz="1100" dirty="0"/>
           </a:p>
@@ -3778,18 +3856,57 @@
       </p:sp>
       <p:sp>
         <p:nvSpPr>
-          <p:cNvPr id="7" name="Shape 4"/>
+          <p:cNvPr id="8" name="Text 6"/>
+          <p:cNvSpPr txBox="1"/>
+          <p:nvPr/>
+        </p:nvSpPr>
+        <p:spPr>
+          <a:xfrm>
+            <a:off x="566928" y="3108960"/>
+            <a:ext cx="1325880" cy="640080"/>
+          </a:xfrm>
+          <a:prstGeom prst="rect">
+            <a:avLst/>
+          </a:prstGeom>
+          <a:noFill/>
+          <a:ln/>
+        </p:spPr>
+        <p:txBody>
+          <a:bodyPr wrap="square" lIns="0" tIns="0" rIns="0" bIns="0" rtlCol="0" anchor="t"/>
+          <a:lstStyle/>
+          <a:p>
+            <a:pPr indent="0" marL="0">
+              <a:buNone/>
+            </a:pPr>
+            <a:r>
+              <a:rPr lang="en-US" sz="1000" i="1" dirty="0">
+                <a:solidFill>
+                  <a:schemeClr val="accent3"/>
+                </a:solidFill>
+                <a:latin typeface="Calibri" pitchFamily="34" charset="0"/>
+                <a:ea typeface="Calibri" pitchFamily="34" charset="-122"/>
+                <a:cs typeface="Calibri" pitchFamily="34" charset="-120"/>
+              </a:rPr>
+              <a:t>Why: tests what CLIP knows without labels</a:t>
+            </a:r>
+            <a:endParaRPr lang="en-US" sz="1000" dirty="0"/>
+          </a:p>
+        </p:txBody>
+      </p:sp>
+      <p:sp>
+        <p:nvSpPr>
+          <p:cNvPr id="9" name="Shape 7"/>
           <p:cNvSpPr/>
           <p:nvPr/>
         </p:nvSpPr>
         <p:spPr>
           <a:xfrm>
-            <a:off x="6217920" y="2286000"/>
-            <a:ext cx="2560320" cy="960120"/>
+            <a:off x="2103120" y="1234440"/>
+            <a:ext cx="1536192" cy="2514600"/>
           </a:xfrm>
           <a:prstGeom prst="roundRect">
             <a:avLst>
-              <a:gd name="adj" fmla="val 7619"/>
+              <a:gd name="adj" fmla="val 4762"/>
             </a:avLst>
           </a:prstGeom>
           <a:solidFill>
@@ -3805,77 +3922,141 @@
       </p:sp>
       <p:sp>
         <p:nvSpPr>
-          <p:cNvPr id="8" name="Text 5"/>
-          <p:cNvSpPr txBox="1"/>
-          <p:nvPr/>
-        </p:nvSpPr>
-        <p:spPr>
-          <a:xfrm>
-            <a:off x="6355080" y="2359152"/>
-            <a:ext cx="2286000" cy="457200"/>
-          </a:xfrm>
-          <a:prstGeom prst="rect">
-            <a:avLst/>
-          </a:prstGeom>
-          <a:noFill/>
-          <a:ln/>
-        </p:spPr>
-        <p:txBody>
-          <a:bodyPr wrap="square" lIns="0" tIns="0" rIns="0" bIns="0" rtlCol="0" anchor="t"/>
-          <a:lstStyle/>
-          <a:p>
-            <a:pPr indent="0" marL="0">
-              <a:buNone/>
-            </a:pPr>
-            <a:r>
-              <a:rPr lang="en-US" sz="2400" b="1" dirty="0">
-                <a:solidFill>
-                  <a:schemeClr val="accent2"/>
+          <p:cNvPr id="10" name="Shape 8"/>
+          <p:cNvSpPr/>
+          <p:nvPr/>
+        </p:nvSpPr>
+        <p:spPr>
+          <a:xfrm>
+            <a:off x="2103120" y="1234440"/>
+            <a:ext cx="1536192" cy="82296"/>
+          </a:xfrm>
+          <a:prstGeom prst="rect">
+            <a:avLst/>
+          </a:prstGeom>
+          <a:solidFill>
+            <a:schemeClr val="accent4"/>
+          </a:solidFill>
+          <a:ln w="12700">
+            <a:solidFill>
+              <a:schemeClr val="accent4"/>
+            </a:solidFill>
+            <a:prstDash val="solid"/>
+          </a:ln>
+        </p:spPr>
+      </p:sp>
+      <p:sp>
+        <p:nvSpPr>
+          <p:cNvPr id="11" name="Text 9"/>
+          <p:cNvSpPr txBox="1"/>
+          <p:nvPr/>
+        </p:nvSpPr>
+        <p:spPr>
+          <a:xfrm>
+            <a:off x="2212848" y="1417320"/>
+            <a:ext cx="1325880" cy="548640"/>
+          </a:xfrm>
+          <a:prstGeom prst="rect">
+            <a:avLst/>
+          </a:prstGeom>
+          <a:noFill/>
+          <a:ln/>
+        </p:spPr>
+        <p:txBody>
+          <a:bodyPr wrap="square" lIns="0" tIns="0" rIns="0" bIns="0" rtlCol="0" anchor="t"/>
+          <a:lstStyle/>
+          <a:p>
+            <a:pPr indent="0" marL="0">
+              <a:buNone/>
+            </a:pPr>
+            <a:r>
+              <a:rPr lang="en-US" sz="1400" b="1" dirty="0">
+                <a:solidFill>
+                  <a:schemeClr val="tx1"/>
                 </a:solidFill>
                 <a:latin typeface="Cambria" pitchFamily="34" charset="0"/>
                 <a:ea typeface="Cambria" pitchFamily="34" charset="-122"/>
                 <a:cs typeface="Cambria" pitchFamily="34" charset="-120"/>
               </a:rPr>
-              <a:t>+12.7 pts</a:t>
-            </a:r>
-            <a:endParaRPr lang="en-US" sz="2400" dirty="0"/>
-          </a:p>
-        </p:txBody>
-      </p:sp>
-      <p:sp>
-        <p:nvSpPr>
-          <p:cNvPr id="9" name="Text 6"/>
-          <p:cNvSpPr txBox="1"/>
-          <p:nvPr/>
-        </p:nvSpPr>
-        <p:spPr>
-          <a:xfrm>
-            <a:off x="6355080" y="2816352"/>
-            <a:ext cx="2286000" cy="393192"/>
-          </a:xfrm>
-          <a:prstGeom prst="rect">
-            <a:avLst/>
-          </a:prstGeom>
-          <a:noFill/>
-          <a:ln/>
-        </p:spPr>
-        <p:txBody>
-          <a:bodyPr wrap="square" lIns="0" tIns="0" rIns="0" bIns="0" rtlCol="0" anchor="t"/>
-          <a:lstStyle/>
-          <a:p>
-            <a:pPr indent="0" marL="0">
-              <a:buNone/>
-            </a:pPr>
-            <a:r>
-              <a:rPr lang="en-US" sz="1100" dirty="0">
-                <a:solidFill>
-                  <a:schemeClr val="tx1"/>
+              <a:t>Frozen CLIP + LR</a:t>
+            </a:r>
+            <a:endParaRPr lang="en-US" sz="1400" dirty="0"/>
+          </a:p>
+        </p:txBody>
+      </p:sp>
+      <p:sp>
+        <p:nvSpPr>
+          <p:cNvPr id="12" name="Text 10"/>
+          <p:cNvSpPr txBox="1"/>
+          <p:nvPr/>
+        </p:nvSpPr>
+        <p:spPr>
+          <a:xfrm>
+            <a:off x="2212848" y="2011680"/>
+            <a:ext cx="1325880" cy="365760"/>
+          </a:xfrm>
+          <a:prstGeom prst="rect">
+            <a:avLst/>
+          </a:prstGeom>
+          <a:noFill/>
+          <a:ln/>
+        </p:spPr>
+        <p:txBody>
+          <a:bodyPr wrap="square" lIns="0" tIns="0" rIns="0" bIns="0" rtlCol="0" anchor="t"/>
+          <a:lstStyle/>
+          <a:p>
+            <a:pPr indent="0" marL="0">
+              <a:buNone/>
+            </a:pPr>
+            <a:r>
+              <a:rPr lang="en-US" sz="1200" b="1" dirty="0">
+                <a:solidFill>
+                  <a:schemeClr val="accent1"/>
                 </a:solidFill>
                 <a:latin typeface="Calibri" pitchFamily="34" charset="0"/>
                 <a:ea typeface="Calibri" pitchFamily="34" charset="-122"/>
                 <a:cs typeface="Calibri" pitchFamily="34" charset="-120"/>
               </a:rPr>
-              <a:t>at 1 label vs tuned frozen (95% CI 8.4 to 17.1)</a:t>
+              <a:t>3k parameters</a:t>
+            </a:r>
+            <a:endParaRPr lang="en-US" sz="1200" dirty="0"/>
+          </a:p>
+        </p:txBody>
+      </p:sp>
+      <p:sp>
+        <p:nvSpPr>
+          <p:cNvPr id="13" name="Text 11"/>
+          <p:cNvSpPr txBox="1"/>
+          <p:nvPr/>
+        </p:nvSpPr>
+        <p:spPr>
+          <a:xfrm>
+            <a:off x="2212848" y="2560320"/>
+            <a:ext cx="1325880" cy="502920"/>
+          </a:xfrm>
+          <a:prstGeom prst="rect">
+            <a:avLst/>
+          </a:prstGeom>
+          <a:noFill/>
+          <a:ln/>
+        </p:spPr>
+        <p:txBody>
+          <a:bodyPr wrap="square" lIns="0" tIns="0" rIns="0" bIns="0" rtlCol="0" anchor="t"/>
+          <a:lstStyle/>
+          <a:p>
+            <a:pPr indent="0" marL="0">
+              <a:buNone/>
+            </a:pPr>
+            <a:r>
+              <a:rPr lang="en-US" sz="1100" dirty="0">
+                <a:solidFill>
+                  <a:schemeClr val="tx1"/>
+                </a:solidFill>
+                <a:latin typeface="Calibri" pitchFamily="34" charset="0"/>
+                <a:ea typeface="Calibri" pitchFamily="34" charset="-122"/>
+                <a:cs typeface="Calibri" pitchFamily="34" charset="-120"/>
+              </a:rPr>
+              <a:t>Linear classifier on frozen features</a:t>
             </a:r>
             <a:endParaRPr lang="en-US" sz="1100" dirty="0"/>
           </a:p>
@@ -3883,18 +4064,57 @@
       </p:sp>
       <p:sp>
         <p:nvSpPr>
-          <p:cNvPr id="10" name="Shape 7"/>
+          <p:cNvPr id="14" name="Text 12"/>
+          <p:cNvSpPr txBox="1"/>
+          <p:nvPr/>
+        </p:nvSpPr>
+        <p:spPr>
+          <a:xfrm>
+            <a:off x="2212848" y="3108960"/>
+            <a:ext cx="1325880" cy="640080"/>
+          </a:xfrm>
+          <a:prstGeom prst="rect">
+            <a:avLst/>
+          </a:prstGeom>
+          <a:noFill/>
+          <a:ln/>
+        </p:spPr>
+        <p:txBody>
+          <a:bodyPr wrap="square" lIns="0" tIns="0" rIns="0" bIns="0" rtlCol="0" anchor="t"/>
+          <a:lstStyle/>
+          <a:p>
+            <a:pPr indent="0" marL="0">
+              <a:buNone/>
+            </a:pPr>
+            <a:r>
+              <a:rPr lang="en-US" sz="1000" i="1" dirty="0">
+                <a:solidFill>
+                  <a:schemeClr val="accent3"/>
+                </a:solidFill>
+                <a:latin typeface="Calibri" pitchFamily="34" charset="0"/>
+                <a:ea typeface="Calibri" pitchFamily="34" charset="-122"/>
+                <a:cs typeface="Calibri" pitchFamily="34" charset="-120"/>
+              </a:rPr>
+              <a:t>Why: cheap baseline, tuned fairly</a:t>
+            </a:r>
+            <a:endParaRPr lang="en-US" sz="1000" dirty="0"/>
+          </a:p>
+        </p:txBody>
+      </p:sp>
+      <p:sp>
+        <p:nvSpPr>
+          <p:cNvPr id="15" name="Shape 13"/>
           <p:cNvSpPr/>
           <p:nvPr/>
         </p:nvSpPr>
         <p:spPr>
           <a:xfrm>
-            <a:off x="6217920" y="3383280"/>
-            <a:ext cx="2560320" cy="960120"/>
+            <a:off x="3749040" y="1234440"/>
+            <a:ext cx="1536192" cy="2514600"/>
           </a:xfrm>
           <a:prstGeom prst="roundRect">
             <a:avLst>
-              <a:gd name="adj" fmla="val 7619"/>
+              <a:gd name="adj" fmla="val 4762"/>
             </a:avLst>
           </a:prstGeom>
           <a:solidFill>
@@ -3910,108 +4130,133 @@
       </p:sp>
       <p:sp>
         <p:nvSpPr>
-          <p:cNvPr id="11" name="Text 8"/>
-          <p:cNvSpPr txBox="1"/>
-          <p:nvPr/>
-        </p:nvSpPr>
-        <p:spPr>
-          <a:xfrm>
-            <a:off x="6355080" y="3456432"/>
-            <a:ext cx="2286000" cy="457200"/>
-          </a:xfrm>
-          <a:prstGeom prst="rect">
-            <a:avLst/>
-          </a:prstGeom>
-          <a:noFill/>
-          <a:ln/>
-        </p:spPr>
-        <p:txBody>
-          <a:bodyPr wrap="square" lIns="0" tIns="0" rIns="0" bIns="0" rtlCol="0" anchor="t"/>
-          <a:lstStyle/>
-          <a:p>
-            <a:pPr indent="0" marL="0">
-              <a:buNone/>
-            </a:pPr>
-            <a:r>
-              <a:rPr lang="en-US" sz="2400" b="1" dirty="0">
-                <a:solidFill>
-                  <a:schemeClr val="accent4"/>
+          <p:cNvPr id="16" name="Shape 14"/>
+          <p:cNvSpPr/>
+          <p:nvPr/>
+        </p:nvSpPr>
+        <p:spPr>
+          <a:xfrm>
+            <a:off x="3749040" y="1234440"/>
+            <a:ext cx="1536192" cy="82296"/>
+          </a:xfrm>
+          <a:prstGeom prst="rect">
+            <a:avLst/>
+          </a:prstGeom>
+          <a:solidFill>
+            <a:schemeClr val="accent2"/>
+          </a:solidFill>
+          <a:ln w="12700">
+            <a:solidFill>
+              <a:schemeClr val="accent2"/>
+            </a:solidFill>
+            <a:prstDash val="solid"/>
+          </a:ln>
+        </p:spPr>
+      </p:sp>
+      <p:sp>
+        <p:nvSpPr>
+          <p:cNvPr id="17" name="Text 15"/>
+          <p:cNvSpPr txBox="1"/>
+          <p:nvPr/>
+        </p:nvSpPr>
+        <p:spPr>
+          <a:xfrm>
+            <a:off x="3858768" y="1417320"/>
+            <a:ext cx="1325880" cy="548640"/>
+          </a:xfrm>
+          <a:prstGeom prst="rect">
+            <a:avLst/>
+          </a:prstGeom>
+          <a:noFill/>
+          <a:ln/>
+        </p:spPr>
+        <p:txBody>
+          <a:bodyPr wrap="square" lIns="0" tIns="0" rIns="0" bIns="0" rtlCol="0" anchor="t"/>
+          <a:lstStyle/>
+          <a:p>
+            <a:pPr indent="0" marL="0">
+              <a:buNone/>
+            </a:pPr>
+            <a:r>
+              <a:rPr lang="en-US" sz="1400" b="1" dirty="0">
+                <a:solidFill>
+                  <a:schemeClr val="tx1"/>
                 </a:solidFill>
                 <a:latin typeface="Cambria" pitchFamily="34" charset="0"/>
                 <a:ea typeface="Cambria" pitchFamily="34" charset="-122"/>
                 <a:cs typeface="Cambria" pitchFamily="34" charset="-120"/>
               </a:rPr>
-              <a:t>about 1 pt</a:t>
-            </a:r>
-            <a:endParaRPr lang="en-US" sz="2400" dirty="0"/>
-          </a:p>
-        </p:txBody>
-      </p:sp>
-      <p:sp>
-        <p:nvSpPr>
-          <p:cNvPr id="12" name="Text 9"/>
-          <p:cNvSpPr txBox="1"/>
-          <p:nvPr/>
-        </p:nvSpPr>
-        <p:spPr>
-          <a:xfrm>
-            <a:off x="6355080" y="3913632"/>
-            <a:ext cx="2286000" cy="393192"/>
-          </a:xfrm>
-          <a:prstGeom prst="rect">
-            <a:avLst/>
-          </a:prstGeom>
-          <a:noFill/>
-          <a:ln/>
-        </p:spPr>
-        <p:txBody>
-          <a:bodyPr wrap="square" lIns="0" tIns="0" rIns="0" bIns="0" rtlCol="0" anchor="t"/>
-          <a:lstStyle/>
-          <a:p>
-            <a:pPr indent="0" marL="0">
-              <a:buNone/>
-            </a:pPr>
-            <a:r>
-              <a:rPr lang="en-US" sz="1100" dirty="0">
-                <a:solidFill>
-                  <a:schemeClr val="tx1"/>
+              <a:t>Partial fine-tune</a:t>
+            </a:r>
+            <a:endParaRPr lang="en-US" sz="1400" dirty="0"/>
+          </a:p>
+        </p:txBody>
+      </p:sp>
+      <p:sp>
+        <p:nvSpPr>
+          <p:cNvPr id="18" name="Text 16"/>
+          <p:cNvSpPr txBox="1"/>
+          <p:nvPr/>
+        </p:nvSpPr>
+        <p:spPr>
+          <a:xfrm>
+            <a:off x="3858768" y="2011680"/>
+            <a:ext cx="1325880" cy="365760"/>
+          </a:xfrm>
+          <a:prstGeom prst="rect">
+            <a:avLst/>
+          </a:prstGeom>
+          <a:noFill/>
+          <a:ln/>
+        </p:spPr>
+        <p:txBody>
+          <a:bodyPr wrap="square" lIns="0" tIns="0" rIns="0" bIns="0" rtlCol="0" anchor="t"/>
+          <a:lstStyle/>
+          <a:p>
+            <a:pPr indent="0" marL="0">
+              <a:buNone/>
+            </a:pPr>
+            <a:r>
+              <a:rPr lang="en-US" sz="1200" b="1" dirty="0">
+                <a:solidFill>
+                  <a:schemeClr val="accent1"/>
                 </a:solidFill>
                 <a:latin typeface="Calibri" pitchFamily="34" charset="0"/>
                 <a:ea typeface="Calibri" pitchFamily="34" charset="-122"/>
                 <a:cs typeface="Calibri" pitchFamily="34" charset="-120"/>
               </a:rPr>
-              <a:t>difference from 50 labels on; interval includes zero</a:t>
-            </a:r>
-            <a:endParaRPr lang="en-US" sz="1100" dirty="0"/>
-          </a:p>
-        </p:txBody>
-      </p:sp>
-      <p:sp>
-        <p:nvSpPr>
-          <p:cNvPr id="13" name="Text 10"/>
-          <p:cNvSpPr txBox="1"/>
-          <p:nvPr/>
-        </p:nvSpPr>
-        <p:spPr>
-          <a:xfrm>
-            <a:off x="457200" y="3886200"/>
-            <a:ext cx="5669280" cy="640080"/>
-          </a:xfrm>
-          <a:prstGeom prst="rect">
-            <a:avLst/>
-          </a:prstGeom>
-          <a:noFill/>
-          <a:ln/>
-        </p:spPr>
-        <p:txBody>
-          <a:bodyPr wrap="square" lIns="0" tIns="0" rIns="0" bIns="0" rtlCol="0" anchor="t"/>
-          <a:lstStyle/>
-          <a:p>
-            <a:pPr indent="0" marL="0">
-              <a:buNone/>
-            </a:pPr>
-            <a:r>
-              <a:rPr lang="en-US" sz="1200" dirty="0">
+              <a:t>about 15M parameters</a:t>
+            </a:r>
+            <a:endParaRPr lang="en-US" sz="1200" dirty="0"/>
+          </a:p>
+        </p:txBody>
+      </p:sp>
+      <p:sp>
+        <p:nvSpPr>
+          <p:cNvPr id="19" name="Text 17"/>
+          <p:cNvSpPr txBox="1"/>
+          <p:nvPr/>
+        </p:nvSpPr>
+        <p:spPr>
+          <a:xfrm>
+            <a:off x="3858768" y="2560320"/>
+            <a:ext cx="1325880" cy="502920"/>
+          </a:xfrm>
+          <a:prstGeom prst="rect">
+            <a:avLst/>
+          </a:prstGeom>
+          <a:noFill/>
+          <a:ln/>
+        </p:spPr>
+        <p:txBody>
+          <a:bodyPr wrap="square" lIns="0" tIns="0" rIns="0" bIns="0" rtlCol="0" anchor="t"/>
+          <a:lstStyle/>
+          <a:p>
+            <a:pPr indent="0" marL="0">
+              <a:buNone/>
+            </a:pPr>
+            <a:r>
+              <a:rPr lang="en-US" sz="1100" dirty="0">
                 <a:solidFill>
                   <a:schemeClr val="tx1"/>
                 </a:solidFill>
@@ -4019,38 +4264,38 @@
                 <a:ea typeface="Calibri" pitchFamily="34" charset="-122"/>
                 <a:cs typeface="Calibri" pitchFamily="34" charset="-120"/>
               </a:rPr>
-              <a:t>Partial fine-tuning is 5 and 3 points behind full at 1 and 2 labels, then equal. CLIP beats the ImageNet ViT only at 1 label (+8.4 pts).</a:t>
-            </a:r>
-            <a:endParaRPr lang="en-US" sz="1200" dirty="0"/>
-          </a:p>
-        </p:txBody>
-      </p:sp>
-      <p:sp>
-        <p:nvSpPr>
-          <p:cNvPr id="14" name="Text 11"/>
-          <p:cNvSpPr txBox="1"/>
-          <p:nvPr/>
-        </p:nvSpPr>
-        <p:spPr>
-          <a:xfrm>
-            <a:off x="457200" y="4754880"/>
-            <a:ext cx="7772400" cy="228600"/>
-          </a:xfrm>
-          <a:prstGeom prst="rect">
-            <a:avLst/>
-          </a:prstGeom>
-          <a:noFill/>
-          <a:ln/>
-        </p:spPr>
-        <p:txBody>
-          <a:bodyPr wrap="square" lIns="0" tIns="0" rIns="0" bIns="0" rtlCol="0" anchor="t"/>
-          <a:lstStyle/>
-          <a:p>
-            <a:pPr indent="0" marL="0">
-              <a:buNone/>
-            </a:pPr>
-            <a:r>
-              <a:rPr lang="en-US" sz="900" dirty="0">
+              <a:t>Last 2 of 12 blocks</a:t>
+            </a:r>
+            <a:endParaRPr lang="en-US" sz="1100" dirty="0"/>
+          </a:p>
+        </p:txBody>
+      </p:sp>
+      <p:sp>
+        <p:nvSpPr>
+          <p:cNvPr id="20" name="Text 18"/>
+          <p:cNvSpPr txBox="1"/>
+          <p:nvPr/>
+        </p:nvSpPr>
+        <p:spPr>
+          <a:xfrm>
+            <a:off x="3858768" y="3108960"/>
+            <a:ext cx="1325880" cy="640080"/>
+          </a:xfrm>
+          <a:prstGeom prst="rect">
+            <a:avLst/>
+          </a:prstGeom>
+          <a:noFill/>
+          <a:ln/>
+        </p:spPr>
+        <p:txBody>
+          <a:bodyPr wrap="square" lIns="0" tIns="0" rIns="0" bIns="0" rtlCol="0" anchor="t"/>
+          <a:lstStyle/>
+          <a:p>
+            <a:pPr indent="0" marL="0">
+              <a:buNone/>
+            </a:pPr>
+            <a:r>
+              <a:rPr lang="en-US" sz="1000" i="1" dirty="0">
                 <a:solidFill>
                   <a:schemeClr val="accent3"/>
                 </a:solidFill>
@@ -4058,9 +4303,521 @@
                 <a:ea typeface="Calibri" pitchFamily="34" charset="-122"/>
                 <a:cs typeface="Calibri" pitchFamily="34" charset="-120"/>
               </a:rPr>
-              <a:t>Mean over 5 folds, shaded band is one SD. Intervals are approximate because folds share training images.</a:t>
-            </a:r>
-            <a:endParaRPr lang="en-US" sz="900" dirty="0"/>
+              <a:t>Why: cheaper adaptation, fewer weights changed</a:t>
+            </a:r>
+            <a:endParaRPr lang="en-US" sz="1000" dirty="0"/>
+          </a:p>
+        </p:txBody>
+      </p:sp>
+      <p:sp>
+        <p:nvSpPr>
+          <p:cNvPr id="21" name="Shape 19"/>
+          <p:cNvSpPr/>
+          <p:nvPr/>
+        </p:nvSpPr>
+        <p:spPr>
+          <a:xfrm>
+            <a:off x="5394960" y="1234440"/>
+            <a:ext cx="1536192" cy="2514600"/>
+          </a:xfrm>
+          <a:prstGeom prst="roundRect">
+            <a:avLst>
+              <a:gd name="adj" fmla="val 4762"/>
+            </a:avLst>
+          </a:prstGeom>
+          <a:solidFill>
+            <a:schemeClr val="bg2"/>
+          </a:solidFill>
+          <a:ln w="12700">
+            <a:solidFill>
+              <a:schemeClr val="bg2"/>
+            </a:solidFill>
+            <a:prstDash val="solid"/>
+          </a:ln>
+        </p:spPr>
+      </p:sp>
+      <p:sp>
+        <p:nvSpPr>
+          <p:cNvPr id="22" name="Shape 20"/>
+          <p:cNvSpPr/>
+          <p:nvPr/>
+        </p:nvSpPr>
+        <p:spPr>
+          <a:xfrm>
+            <a:off x="5394960" y="1234440"/>
+            <a:ext cx="1536192" cy="82296"/>
+          </a:xfrm>
+          <a:prstGeom prst="rect">
+            <a:avLst/>
+          </a:prstGeom>
+          <a:solidFill>
+            <a:schemeClr val="accent1"/>
+          </a:solidFill>
+          <a:ln w="12700">
+            <a:solidFill>
+              <a:schemeClr val="accent1"/>
+            </a:solidFill>
+            <a:prstDash val="solid"/>
+          </a:ln>
+        </p:spPr>
+      </p:sp>
+      <p:sp>
+        <p:nvSpPr>
+          <p:cNvPr id="23" name="Text 21"/>
+          <p:cNvSpPr txBox="1"/>
+          <p:nvPr/>
+        </p:nvSpPr>
+        <p:spPr>
+          <a:xfrm>
+            <a:off x="5504688" y="1417320"/>
+            <a:ext cx="1325880" cy="548640"/>
+          </a:xfrm>
+          <a:prstGeom prst="rect">
+            <a:avLst/>
+          </a:prstGeom>
+          <a:noFill/>
+          <a:ln/>
+        </p:spPr>
+        <p:txBody>
+          <a:bodyPr wrap="square" lIns="0" tIns="0" rIns="0" bIns="0" rtlCol="0" anchor="t"/>
+          <a:lstStyle/>
+          <a:p>
+            <a:pPr indent="0" marL="0">
+              <a:buNone/>
+            </a:pPr>
+            <a:r>
+              <a:rPr lang="en-US" sz="1400" b="1" dirty="0">
+                <a:solidFill>
+                  <a:schemeClr val="tx1"/>
+                </a:solidFill>
+                <a:latin typeface="Cambria" pitchFamily="34" charset="0"/>
+                <a:ea typeface="Cambria" pitchFamily="34" charset="-122"/>
+                <a:cs typeface="Cambria" pitchFamily="34" charset="-120"/>
+              </a:rPr>
+              <a:t>Full fine-tune</a:t>
+            </a:r>
+            <a:endParaRPr lang="en-US" sz="1400" dirty="0"/>
+          </a:p>
+        </p:txBody>
+      </p:sp>
+      <p:sp>
+        <p:nvSpPr>
+          <p:cNvPr id="24" name="Text 22"/>
+          <p:cNvSpPr txBox="1"/>
+          <p:nvPr/>
+        </p:nvSpPr>
+        <p:spPr>
+          <a:xfrm>
+            <a:off x="5504688" y="2011680"/>
+            <a:ext cx="1325880" cy="365760"/>
+          </a:xfrm>
+          <a:prstGeom prst="rect">
+            <a:avLst/>
+          </a:prstGeom>
+          <a:noFill/>
+          <a:ln/>
+        </p:spPr>
+        <p:txBody>
+          <a:bodyPr wrap="square" lIns="0" tIns="0" rIns="0" bIns="0" rtlCol="0" anchor="t"/>
+          <a:lstStyle/>
+          <a:p>
+            <a:pPr indent="0" marL="0">
+              <a:buNone/>
+            </a:pPr>
+            <a:r>
+              <a:rPr lang="en-US" sz="1200" b="1" dirty="0">
+                <a:solidFill>
+                  <a:schemeClr val="accent1"/>
+                </a:solidFill>
+                <a:latin typeface="Calibri" pitchFamily="34" charset="0"/>
+                <a:ea typeface="Calibri" pitchFamily="34" charset="-122"/>
+                <a:cs typeface="Calibri" pitchFamily="34" charset="-120"/>
+              </a:rPr>
+              <a:t>about 86M parameters</a:t>
+            </a:r>
+            <a:endParaRPr lang="en-US" sz="1200" dirty="0"/>
+          </a:p>
+        </p:txBody>
+      </p:sp>
+      <p:sp>
+        <p:nvSpPr>
+          <p:cNvPr id="25" name="Text 23"/>
+          <p:cNvSpPr txBox="1"/>
+          <p:nvPr/>
+        </p:nvSpPr>
+        <p:spPr>
+          <a:xfrm>
+            <a:off x="5504688" y="2560320"/>
+            <a:ext cx="1325880" cy="502920"/>
+          </a:xfrm>
+          <a:prstGeom prst="rect">
+            <a:avLst/>
+          </a:prstGeom>
+          <a:noFill/>
+          <a:ln/>
+        </p:spPr>
+        <p:txBody>
+          <a:bodyPr wrap="square" lIns="0" tIns="0" rIns="0" bIns="0" rtlCol="0" anchor="t"/>
+          <a:lstStyle/>
+          <a:p>
+            <a:pPr indent="0" marL="0">
+              <a:buNone/>
+            </a:pPr>
+            <a:r>
+              <a:rPr lang="en-US" sz="1100" dirty="0">
+                <a:solidFill>
+                  <a:schemeClr val="tx1"/>
+                </a:solidFill>
+                <a:latin typeface="Calibri" pitchFamily="34" charset="0"/>
+                <a:ea typeface="Calibri" pitchFamily="34" charset="-122"/>
+                <a:cs typeface="Calibri" pitchFamily="34" charset="-120"/>
+              </a:rPr>
+              <a:t>CLIP ViT-B/16, all weights</a:t>
+            </a:r>
+            <a:endParaRPr lang="en-US" sz="1100" dirty="0"/>
+          </a:p>
+        </p:txBody>
+      </p:sp>
+      <p:sp>
+        <p:nvSpPr>
+          <p:cNvPr id="26" name="Text 24"/>
+          <p:cNvSpPr txBox="1"/>
+          <p:nvPr/>
+        </p:nvSpPr>
+        <p:spPr>
+          <a:xfrm>
+            <a:off x="5504688" y="3108960"/>
+            <a:ext cx="1325880" cy="640080"/>
+          </a:xfrm>
+          <a:prstGeom prst="rect">
+            <a:avLst/>
+          </a:prstGeom>
+          <a:noFill/>
+          <a:ln/>
+        </p:spPr>
+        <p:txBody>
+          <a:bodyPr wrap="square" lIns="0" tIns="0" rIns="0" bIns="0" rtlCol="0" anchor="t"/>
+          <a:lstStyle/>
+          <a:p>
+            <a:pPr indent="0" marL="0">
+              <a:buNone/>
+            </a:pPr>
+            <a:r>
+              <a:rPr lang="en-US" sz="1000" i="1" dirty="0">
+                <a:solidFill>
+                  <a:schemeClr val="accent3"/>
+                </a:solidFill>
+                <a:latin typeface="Calibri" pitchFamily="34" charset="0"/>
+                <a:ea typeface="Calibri" pitchFamily="34" charset="-122"/>
+                <a:cs typeface="Calibri" pitchFamily="34" charset="-120"/>
+              </a:rPr>
+              <a:t>Why: does full adaptation pay off? CLIP has broad features</a:t>
+            </a:r>
+            <a:endParaRPr lang="en-US" sz="1000" dirty="0"/>
+          </a:p>
+        </p:txBody>
+      </p:sp>
+      <p:sp>
+        <p:nvSpPr>
+          <p:cNvPr id="27" name="Shape 25"/>
+          <p:cNvSpPr/>
+          <p:nvPr/>
+        </p:nvSpPr>
+        <p:spPr>
+          <a:xfrm>
+            <a:off x="7040880" y="1234440"/>
+            <a:ext cx="1536192" cy="2514600"/>
+          </a:xfrm>
+          <a:prstGeom prst="roundRect">
+            <a:avLst>
+              <a:gd name="adj" fmla="val 4762"/>
+            </a:avLst>
+          </a:prstGeom>
+          <a:solidFill>
+            <a:schemeClr val="bg2"/>
+          </a:solidFill>
+          <a:ln w="12700">
+            <a:solidFill>
+              <a:schemeClr val="bg2"/>
+            </a:solidFill>
+            <a:prstDash val="solid"/>
+          </a:ln>
+        </p:spPr>
+      </p:sp>
+      <p:sp>
+        <p:nvSpPr>
+          <p:cNvPr id="28" name="Shape 26"/>
+          <p:cNvSpPr/>
+          <p:nvPr/>
+        </p:nvSpPr>
+        <p:spPr>
+          <a:xfrm>
+            <a:off x="7040880" y="1234440"/>
+            <a:ext cx="1536192" cy="82296"/>
+          </a:xfrm>
+          <a:prstGeom prst="rect">
+            <a:avLst/>
+          </a:prstGeom>
+          <a:solidFill>
+            <a:schemeClr val="accent5"/>
+          </a:solidFill>
+          <a:ln w="12700">
+            <a:solidFill>
+              <a:schemeClr val="accent5"/>
+            </a:solidFill>
+            <a:prstDash val="solid"/>
+          </a:ln>
+        </p:spPr>
+      </p:sp>
+      <p:sp>
+        <p:nvSpPr>
+          <p:cNvPr id="29" name="Text 27"/>
+          <p:cNvSpPr txBox="1"/>
+          <p:nvPr/>
+        </p:nvSpPr>
+        <p:spPr>
+          <a:xfrm>
+            <a:off x="7150608" y="1417320"/>
+            <a:ext cx="1325880" cy="548640"/>
+          </a:xfrm>
+          <a:prstGeom prst="rect">
+            <a:avLst/>
+          </a:prstGeom>
+          <a:noFill/>
+          <a:ln/>
+        </p:spPr>
+        <p:txBody>
+          <a:bodyPr wrap="square" lIns="0" tIns="0" rIns="0" bIns="0" rtlCol="0" anchor="t"/>
+          <a:lstStyle/>
+          <a:p>
+            <a:pPr indent="0" marL="0">
+              <a:buNone/>
+            </a:pPr>
+            <a:r>
+              <a:rPr lang="en-US" sz="1400" b="1" dirty="0">
+                <a:solidFill>
+                  <a:schemeClr val="tx1"/>
+                </a:solidFill>
+                <a:latin typeface="Cambria" pitchFamily="34" charset="0"/>
+                <a:ea typeface="Cambria" pitchFamily="34" charset="-122"/>
+                <a:cs typeface="Cambria" pitchFamily="34" charset="-120"/>
+              </a:rPr>
+              <a:t>ImageNet ViT</a:t>
+            </a:r>
+            <a:endParaRPr lang="en-US" sz="1400" dirty="0"/>
+          </a:p>
+        </p:txBody>
+      </p:sp>
+      <p:sp>
+        <p:nvSpPr>
+          <p:cNvPr id="30" name="Text 28"/>
+          <p:cNvSpPr txBox="1"/>
+          <p:nvPr/>
+        </p:nvSpPr>
+        <p:spPr>
+          <a:xfrm>
+            <a:off x="7150608" y="2011680"/>
+            <a:ext cx="1325880" cy="365760"/>
+          </a:xfrm>
+          <a:prstGeom prst="rect">
+            <a:avLst/>
+          </a:prstGeom>
+          <a:noFill/>
+          <a:ln/>
+        </p:spPr>
+        <p:txBody>
+          <a:bodyPr wrap="square" lIns="0" tIns="0" rIns="0" bIns="0" rtlCol="0" anchor="t"/>
+          <a:lstStyle/>
+          <a:p>
+            <a:pPr indent="0" marL="0">
+              <a:buNone/>
+            </a:pPr>
+            <a:r>
+              <a:rPr lang="en-US" sz="1200" b="1" dirty="0">
+                <a:solidFill>
+                  <a:schemeClr val="accent1"/>
+                </a:solidFill>
+                <a:latin typeface="Calibri" pitchFamily="34" charset="0"/>
+                <a:ea typeface="Calibri" pitchFamily="34" charset="-122"/>
+                <a:cs typeface="Calibri" pitchFamily="34" charset="-120"/>
+              </a:rPr>
+              <a:t>about 86M parameters</a:t>
+            </a:r>
+            <a:endParaRPr lang="en-US" sz="1200" dirty="0"/>
+          </a:p>
+        </p:txBody>
+      </p:sp>
+      <p:sp>
+        <p:nvSpPr>
+          <p:cNvPr id="31" name="Text 29"/>
+          <p:cNvSpPr txBox="1"/>
+          <p:nvPr/>
+        </p:nvSpPr>
+        <p:spPr>
+          <a:xfrm>
+            <a:off x="7150608" y="2560320"/>
+            <a:ext cx="1325880" cy="502920"/>
+          </a:xfrm>
+          <a:prstGeom prst="rect">
+            <a:avLst/>
+          </a:prstGeom>
+          <a:noFill/>
+          <a:ln/>
+        </p:spPr>
+        <p:txBody>
+          <a:bodyPr wrap="square" lIns="0" tIns="0" rIns="0" bIns="0" rtlCol="0" anchor="t"/>
+          <a:lstStyle/>
+          <a:p>
+            <a:pPr indent="0" marL="0">
+              <a:buNone/>
+            </a:pPr>
+            <a:r>
+              <a:rPr lang="en-US" sz="1100" dirty="0">
+                <a:solidFill>
+                  <a:schemeClr val="tx1"/>
+                </a:solidFill>
+                <a:latin typeface="Calibri" pitchFamily="34" charset="0"/>
+                <a:ea typeface="Calibri" pitchFamily="34" charset="-122"/>
+                <a:cs typeface="Calibri" pitchFamily="34" charset="-120"/>
+              </a:rPr>
+              <a:t>Reference, other pretraining</a:t>
+            </a:r>
+            <a:endParaRPr lang="en-US" sz="1100" dirty="0"/>
+          </a:p>
+        </p:txBody>
+      </p:sp>
+      <p:sp>
+        <p:nvSpPr>
+          <p:cNvPr id="32" name="Text 30"/>
+          <p:cNvSpPr txBox="1"/>
+          <p:nvPr/>
+        </p:nvSpPr>
+        <p:spPr>
+          <a:xfrm>
+            <a:off x="7150608" y="3108960"/>
+            <a:ext cx="1325880" cy="640080"/>
+          </a:xfrm>
+          <a:prstGeom prst="rect">
+            <a:avLst/>
+          </a:prstGeom>
+          <a:noFill/>
+          <a:ln/>
+        </p:spPr>
+        <p:txBody>
+          <a:bodyPr wrap="square" lIns="0" tIns="0" rIns="0" bIns="0" rtlCol="0" anchor="t"/>
+          <a:lstStyle/>
+          <a:p>
+            <a:pPr indent="0" marL="0">
+              <a:buNone/>
+            </a:pPr>
+            <a:r>
+              <a:rPr lang="en-US" sz="1000" i="1" dirty="0">
+                <a:solidFill>
+                  <a:schemeClr val="accent3"/>
+                </a:solidFill>
+                <a:latin typeface="Calibri" pitchFamily="34" charset="0"/>
+                <a:ea typeface="Calibri" pitchFamily="34" charset="-122"/>
+                <a:cs typeface="Calibri" pitchFamily="34" charset="-120"/>
+              </a:rPr>
+              <a:t>Why: checks whether CLIP pretraining matters</a:t>
+            </a:r>
+            <a:endParaRPr lang="en-US" sz="1000" dirty="0"/>
+          </a:p>
+        </p:txBody>
+      </p:sp>
+      <p:sp>
+        <p:nvSpPr>
+          <p:cNvPr id="33" name="Text 31"/>
+          <p:cNvSpPr txBox="1"/>
+          <p:nvPr/>
+        </p:nvSpPr>
+        <p:spPr>
+          <a:xfrm>
+            <a:off x="457200" y="3840480"/>
+            <a:ext cx="8229600" cy="868680"/>
+          </a:xfrm>
+          <a:prstGeom prst="rect">
+            <a:avLst/>
+          </a:prstGeom>
+          <a:noFill/>
+          <a:ln/>
+        </p:spPr>
+        <p:txBody>
+          <a:bodyPr wrap="square" lIns="0" tIns="0" rIns="0" bIns="0" rtlCol="0" anchor="t"/>
+          <a:lstStyle/>
+          <a:p>
+            <a:pPr indent="0" marL="0">
+              <a:spcAft>
+                <a:spcPts val="400"/>
+              </a:spcAft>
+              <a:buNone/>
+            </a:pPr>
+            <a:r>
+              <a:rPr lang="en-US" sz="1200" b="1" dirty="0">
+                <a:solidFill>
+                  <a:schemeClr val="accent1"/>
+                </a:solidFill>
+                <a:latin typeface="Calibri" pitchFamily="34" charset="0"/>
+                <a:ea typeface="Calibri" pitchFamily="34" charset="-122"/>
+                <a:cs typeface="Calibri" pitchFamily="34" charset="-120"/>
+              </a:rPr>
+              <a:t>Measured: </a:t>
+            </a:r>
+            <a:pPr indent="0" marL="0">
+              <a:spcAft>
+                <a:spcPts val="400"/>
+              </a:spcAft>
+              <a:buNone/>
+            </a:pPr>
+            <a:r>
+              <a:rPr lang="en-US" sz="1200" dirty="0">
+                <a:solidFill>
+                  <a:schemeClr val="tx1"/>
+                </a:solidFill>
+                <a:latin typeface="Calibri" pitchFamily="34" charset="0"/>
+                <a:ea typeface="Calibri" pitchFamily="34" charset="-122"/>
+                <a:cs typeface="Calibri" pitchFamily="34" charset="-120"/>
+              </a:rPr>
+              <a:t>accuracy, log-loss, calibration error, confident mistakes, rare-defect recall, unseen-defect AUROC, blur and noise robustness.</a:t>
+            </a:r>
+            <a:endParaRPr lang="en-US" sz="1200" dirty="0"/>
+          </a:p>
+          <a:p>
+            <a:pPr indent="0" marL="0">
+              <a:spcAft>
+                <a:spcPts val="400"/>
+              </a:spcAft>
+              <a:buNone/>
+            </a:pPr>
+            <a:r>
+              <a:rPr lang="en-US" sz="1200" b="1" dirty="0">
+                <a:solidFill>
+                  <a:schemeClr val="accent1"/>
+                </a:solidFill>
+                <a:latin typeface="Calibri" pitchFamily="34" charset="0"/>
+                <a:ea typeface="Calibri" pitchFamily="34" charset="-122"/>
+                <a:cs typeface="Calibri" pitchFamily="34" charset="-120"/>
+              </a:rPr>
+              <a:t>Compared: </a:t>
+            </a:r>
+            <a:pPr indent="0" marL="0">
+              <a:spcAft>
+                <a:spcPts val="400"/>
+              </a:spcAft>
+              <a:buNone/>
+            </a:pPr>
+            <a:r>
+              <a:rPr lang="en-US" sz="1200" dirty="0">
+                <a:solidFill>
+                  <a:schemeClr val="tx1"/>
+                </a:solidFill>
+                <a:latin typeface="Calibri" pitchFamily="34" charset="0"/>
+                <a:ea typeface="Calibri" pitchFamily="34" charset="-122"/>
+                <a:cs typeface="Calibri" pitchFamily="34" charset="-120"/>
+              </a:rPr>
+              <a:t>paired differences with 95% intervals across folds; frozen baseline also tuned fairly on validation images.</a:t>
+            </a:r>
+            <a:endParaRPr lang="en-US" sz="1200" dirty="0"/>
           </a:p>
         </p:txBody>
       </p:sp>
@@ -4166,7 +4923,7 @@
                   <a:srgbClr val="1F2A33"/>
                 </a:solidFill>
               </a:rPr>
-              <a:t>Beyond accuracy: rare defects, unseen defects and confident mistakes</a:t>
+              <a:t>Fine-tuning wins with few labels, and the gap closes by about 50</a:t>
             </a:r>
             <a:endParaRPr lang="en-US" sz="2400" dirty="0"/>
           </a:p>
@@ -4174,7 +4931,7 @@
       </p:sp>
       <p:pic>
         <p:nvPicPr>
-          <p:cNvPr id="3" name="Image 0" descr="/home/claude/fig/fig2_rare_defect.png">    </p:cNvPr>
+          <p:cNvPr id="3" name="Image 0" descr="/home/claude/fig/fig1_learning_curves.png">    </p:cNvPr>
           <p:cNvPicPr>
             <a:picLocks noChangeAspect="1"/>
           </p:cNvPicPr>
@@ -4189,7 +4946,7 @@
         <p:spPr>
           <a:xfrm>
             <a:off x="365760" y="1188720"/>
-            <a:ext cx="4480560" cy="2167128"/>
+            <a:ext cx="5669280" cy="2514600"/>
           </a:xfrm>
           <a:prstGeom prst="rect">
             <a:avLst/>
@@ -4198,53 +4955,14 @@
       </p:pic>
       <p:sp>
         <p:nvSpPr>
-          <p:cNvPr id="4" name="Text 1"/>
-          <p:cNvSpPr txBox="1"/>
-          <p:nvPr/>
-        </p:nvSpPr>
-        <p:spPr>
-          <a:xfrm>
-            <a:off x="457200" y="3401568"/>
-            <a:ext cx="4389120" cy="457200"/>
-          </a:xfrm>
-          <a:prstGeom prst="rect">
-            <a:avLst/>
-          </a:prstGeom>
-          <a:noFill/>
-          <a:ln/>
-        </p:spPr>
-        <p:txBody>
-          <a:bodyPr wrap="square" lIns="0" tIns="0" rIns="0" bIns="0" rtlCol="0" anchor="t"/>
-          <a:lstStyle/>
-          <a:p>
-            <a:pPr indent="0" marL="0">
-              <a:buNone/>
-            </a:pPr>
-            <a:r>
-              <a:rPr lang="en-US" sz="1100" i="1" dirty="0">
-                <a:solidFill>
-                  <a:schemeClr val="accent3"/>
-                </a:solidFill>
-                <a:latin typeface="Calibri" pitchFamily="34" charset="0"/>
-                <a:ea typeface="Calibri" pitchFamily="34" charset="-122"/>
-                <a:cs typeface="Calibri" pitchFamily="34" charset="-120"/>
-              </a:rPr>
-              <a:t>Recall for a rare defect with 1, 5 or 20 labelled examples (others have 50)</a:t>
-            </a:r>
-            <a:endParaRPr lang="en-US" sz="1100" dirty="0"/>
-          </a:p>
-        </p:txBody>
-      </p:sp>
-      <p:sp>
-        <p:nvSpPr>
-          <p:cNvPr id="5" name="Shape 2"/>
+          <p:cNvPr id="4" name="Shape 1"/>
           <p:cNvSpPr/>
           <p:nvPr/>
         </p:nvSpPr>
         <p:spPr>
           <a:xfrm>
-            <a:off x="5029200" y="1188720"/>
-            <a:ext cx="3749040" cy="960120"/>
+            <a:off x="6217920" y="1188720"/>
+            <a:ext cx="2560320" cy="960120"/>
           </a:xfrm>
           <a:prstGeom prst="roundRect">
             <a:avLst>
@@ -4264,14 +4982,14 @@
       </p:sp>
       <p:sp>
         <p:nvSpPr>
-          <p:cNvPr id="6" name="Text 3"/>
-          <p:cNvSpPr txBox="1"/>
-          <p:nvPr/>
-        </p:nvSpPr>
-        <p:spPr>
-          <a:xfrm>
-            <a:off x="5166360" y="1261872"/>
-            <a:ext cx="3474720" cy="457200"/>
+          <p:cNvPr id="5" name="Text 2"/>
+          <p:cNvSpPr txBox="1"/>
+          <p:nvPr/>
+        </p:nvSpPr>
+        <p:spPr>
+          <a:xfrm>
+            <a:off x="6355080" y="1261872"/>
+            <a:ext cx="2286000" cy="457200"/>
           </a:xfrm>
           <a:prstGeom prst="rect">
             <a:avLst/>
@@ -4289,13 +5007,13 @@
             <a:r>
               <a:rPr lang="en-US" sz="2400" b="1" dirty="0">
                 <a:solidFill>
-                  <a:schemeClr val="accent2"/>
+                  <a:schemeClr val="accent1"/>
                 </a:solidFill>
                 <a:latin typeface="Cambria" pitchFamily="34" charset="0"/>
                 <a:ea typeface="Cambria" pitchFamily="34" charset="-122"/>
                 <a:cs typeface="Cambria" pitchFamily="34" charset="-120"/>
               </a:rPr>
-              <a:t>69% vs 6%</a:t>
+              <a:t>3 labels</a:t>
             </a:r>
             <a:endParaRPr lang="en-US" sz="2400" dirty="0"/>
           </a:p>
@@ -4303,14 +5021,14 @@
       </p:sp>
       <p:sp>
         <p:nvSpPr>
-          <p:cNvPr id="7" name="Text 4"/>
-          <p:cNvSpPr txBox="1"/>
-          <p:nvPr/>
-        </p:nvSpPr>
-        <p:spPr>
-          <a:xfrm>
-            <a:off x="5166360" y="1719072"/>
-            <a:ext cx="3474720" cy="393192"/>
+          <p:cNvPr id="6" name="Text 3"/>
+          <p:cNvSpPr txBox="1"/>
+          <p:nvPr/>
+        </p:nvSpPr>
+        <p:spPr>
+          <a:xfrm>
+            <a:off x="6355080" y="1719072"/>
+            <a:ext cx="2286000" cy="393192"/>
           </a:xfrm>
           <a:prstGeom prst="rect">
             <a:avLst/>
@@ -4334,7 +5052,7 @@
                 <a:ea typeface="Calibri" pitchFamily="34" charset="-122"/>
                 <a:cs typeface="Calibri" pitchFamily="34" charset="-120"/>
               </a:rPr>
-              <a:t>rare-defect recall at 1 example: class-weighted vs plain fine-tuning</a:t>
+              <a:t>per class: full fine-tune reaches 95% (tuned frozen: 10)</a:t>
             </a:r>
             <a:endParaRPr lang="en-US" sz="1100" dirty="0"/>
           </a:p>
@@ -4342,14 +5060,14 @@
       </p:sp>
       <p:sp>
         <p:nvSpPr>
-          <p:cNvPr id="8" name="Shape 5"/>
+          <p:cNvPr id="7" name="Shape 4"/>
           <p:cNvSpPr/>
           <p:nvPr/>
         </p:nvSpPr>
         <p:spPr>
           <a:xfrm>
-            <a:off x="5029200" y="2286000"/>
-            <a:ext cx="3749040" cy="960120"/>
+            <a:off x="6217920" y="2286000"/>
+            <a:ext cx="2560320" cy="960120"/>
           </a:xfrm>
           <a:prstGeom prst="roundRect">
             <a:avLst>
@@ -4369,14 +5087,14 @@
       </p:sp>
       <p:sp>
         <p:nvSpPr>
-          <p:cNvPr id="9" name="Text 6"/>
-          <p:cNvSpPr txBox="1"/>
-          <p:nvPr/>
-        </p:nvSpPr>
-        <p:spPr>
-          <a:xfrm>
-            <a:off x="5166360" y="2359152"/>
-            <a:ext cx="3474720" cy="457200"/>
+          <p:cNvPr id="8" name="Text 5"/>
+          <p:cNvSpPr txBox="1"/>
+          <p:nvPr/>
+        </p:nvSpPr>
+        <p:spPr>
+          <a:xfrm>
+            <a:off x="6355080" y="2359152"/>
+            <a:ext cx="2286000" cy="457200"/>
           </a:xfrm>
           <a:prstGeom prst="rect">
             <a:avLst/>
@@ -4394,13 +5112,13 @@
             <a:r>
               <a:rPr lang="en-US" sz="2400" b="1" dirty="0">
                 <a:solidFill>
-                  <a:schemeClr val="accent1"/>
+                  <a:schemeClr val="accent2"/>
                 </a:solidFill>
                 <a:latin typeface="Cambria" pitchFamily="34" charset="0"/>
                 <a:ea typeface="Cambria" pitchFamily="34" charset="-122"/>
                 <a:cs typeface="Cambria" pitchFamily="34" charset="-120"/>
               </a:rPr>
-              <a:t>0.963 vs 0.866</a:t>
+              <a:t>+12.7 pts</a:t>
             </a:r>
             <a:endParaRPr lang="en-US" sz="2400" dirty="0"/>
           </a:p>
@@ -4408,14 +5126,14 @@
       </p:sp>
       <p:sp>
         <p:nvSpPr>
-          <p:cNvPr id="10" name="Text 7"/>
-          <p:cNvSpPr txBox="1"/>
-          <p:nvPr/>
-        </p:nvSpPr>
-        <p:spPr>
-          <a:xfrm>
-            <a:off x="5166360" y="2816352"/>
-            <a:ext cx="3474720" cy="393192"/>
+          <p:cNvPr id="9" name="Text 6"/>
+          <p:cNvSpPr txBox="1"/>
+          <p:nvPr/>
+        </p:nvSpPr>
+        <p:spPr>
+          <a:xfrm>
+            <a:off x="6355080" y="2816352"/>
+            <a:ext cx="2286000" cy="393192"/>
           </a:xfrm>
           <a:prstGeom prst="rect">
             <a:avLst/>
@@ -4439,7 +5157,7 @@
                 <a:ea typeface="Calibri" pitchFamily="34" charset="-122"/>
                 <a:cs typeface="Calibri" pitchFamily="34" charset="-120"/>
               </a:rPr>
-              <a:t>AUROC for spotting a never-seen defect: fine-tuned vs frozen</a:t>
+              <a:t>at 1 label vs tuned frozen (95% CI 8.4 to 17.1)</a:t>
             </a:r>
             <a:endParaRPr lang="en-US" sz="1100" dirty="0"/>
           </a:p>
@@ -4447,14 +5165,14 @@
       </p:sp>
       <p:sp>
         <p:nvSpPr>
-          <p:cNvPr id="11" name="Shape 8"/>
+          <p:cNvPr id="10" name="Shape 7"/>
           <p:cNvSpPr/>
           <p:nvPr/>
         </p:nvSpPr>
         <p:spPr>
           <a:xfrm>
-            <a:off x="5029200" y="3383280"/>
-            <a:ext cx="3749040" cy="960120"/>
+            <a:off x="6217920" y="3383280"/>
+            <a:ext cx="2560320" cy="960120"/>
           </a:xfrm>
           <a:prstGeom prst="roundRect">
             <a:avLst>
@@ -4474,14 +5192,14 @@
       </p:sp>
       <p:sp>
         <p:nvSpPr>
-          <p:cNvPr id="12" name="Text 9"/>
-          <p:cNvSpPr txBox="1"/>
-          <p:nvPr/>
-        </p:nvSpPr>
-        <p:spPr>
-          <a:xfrm>
-            <a:off x="5166360" y="3456432"/>
-            <a:ext cx="3474720" cy="457200"/>
+          <p:cNvPr id="11" name="Text 8"/>
+          <p:cNvSpPr txBox="1"/>
+          <p:nvPr/>
+        </p:nvSpPr>
+        <p:spPr>
+          <a:xfrm>
+            <a:off x="6355080" y="3456432"/>
+            <a:ext cx="2286000" cy="457200"/>
           </a:xfrm>
           <a:prstGeom prst="rect">
             <a:avLst/>
@@ -4499,13 +5217,13 @@
             <a:r>
               <a:rPr lang="en-US" sz="2400" b="1" dirty="0">
                 <a:solidFill>
-                  <a:schemeClr val="accent6"/>
+                  <a:schemeClr val="accent4"/>
                 </a:solidFill>
                 <a:latin typeface="Cambria" pitchFamily="34" charset="0"/>
                 <a:ea typeface="Cambria" pitchFamily="34" charset="-122"/>
                 <a:cs typeface="Cambria" pitchFamily="34" charset="-120"/>
               </a:rPr>
-              <a:t>22%</a:t>
+              <a:t>about 1 pt</a:t>
             </a:r>
             <a:endParaRPr lang="en-US" sz="2400" dirty="0"/>
           </a:p>
@@ -4513,14 +5231,14 @@
       </p:sp>
       <p:sp>
         <p:nvSpPr>
-          <p:cNvPr id="13" name="Text 10"/>
-          <p:cNvSpPr txBox="1"/>
-          <p:nvPr/>
-        </p:nvSpPr>
-        <p:spPr>
-          <a:xfrm>
-            <a:off x="5166360" y="3913632"/>
-            <a:ext cx="3474720" cy="393192"/>
+          <p:cNvPr id="12" name="Text 9"/>
+          <p:cNvSpPr txBox="1"/>
+          <p:nvPr/>
+        </p:nvSpPr>
+        <p:spPr>
+          <a:xfrm>
+            <a:off x="6355080" y="3913632"/>
+            <a:ext cx="2286000" cy="393192"/>
           </a:xfrm>
           <a:prstGeom prst="rect">
             <a:avLst/>
@@ -4544,7 +5262,7 @@
                 <a:ea typeface="Calibri" pitchFamily="34" charset="-122"/>
                 <a:cs typeface="Calibri" pitchFamily="34" charset="-120"/>
               </a:rPr>
-              <a:t>of the fine-tuned model's errors at 1 label are made with 90%+ confidence</a:t>
+              <a:t>difference from 50 labels on; interval includes zero</a:t>
             </a:r>
             <a:endParaRPr lang="en-US" sz="1100" dirty="0"/>
           </a:p>
@@ -4552,30 +5270,30 @@
       </p:sp>
       <p:sp>
         <p:nvSpPr>
-          <p:cNvPr id="14" name="Text 11"/>
-          <p:cNvSpPr txBox="1"/>
-          <p:nvPr/>
-        </p:nvSpPr>
-        <p:spPr>
-          <a:xfrm>
-            <a:off x="457200" y="3977640"/>
-            <a:ext cx="4389120" cy="548640"/>
-          </a:xfrm>
-          <a:prstGeom prst="rect">
-            <a:avLst/>
-          </a:prstGeom>
-          <a:noFill/>
-          <a:ln/>
-        </p:spPr>
-        <p:txBody>
-          <a:bodyPr wrap="square" lIns="0" tIns="0" rIns="0" bIns="0" rtlCol="0" anchor="t"/>
-          <a:lstStyle/>
-          <a:p>
-            <a:pPr indent="0" marL="0">
-              <a:buNone/>
-            </a:pPr>
-            <a:r>
-              <a:rPr lang="en-US" sz="1300" b="1" dirty="0">
+          <p:cNvPr id="13" name="Text 10"/>
+          <p:cNvSpPr txBox="1"/>
+          <p:nvPr/>
+        </p:nvSpPr>
+        <p:spPr>
+          <a:xfrm>
+            <a:off x="457200" y="3886200"/>
+            <a:ext cx="5669280" cy="640080"/>
+          </a:xfrm>
+          <a:prstGeom prst="rect">
+            <a:avLst/>
+          </a:prstGeom>
+          <a:noFill/>
+          <a:ln/>
+        </p:spPr>
+        <p:txBody>
+          <a:bodyPr wrap="square" lIns="0" tIns="0" rIns="0" bIns="0" rtlCol="0" anchor="t"/>
+          <a:lstStyle/>
+          <a:p>
+            <a:pPr indent="0" marL="0">
+              <a:buNone/>
+            </a:pPr>
+            <a:r>
+              <a:rPr lang="en-US" sz="1200" dirty="0">
                 <a:solidFill>
                   <a:schemeClr val="tx1"/>
                 </a:solidFill>
@@ -4583,9 +5301,48 @@
                 <a:ea typeface="Calibri" pitchFamily="34" charset="-122"/>
                 <a:cs typeface="Calibri" pitchFamily="34" charset="-120"/>
               </a:rPr>
-              <a:t>Good average calibration does not make a confident prediction trustworthy.</a:t>
-            </a:r>
-            <a:endParaRPr lang="en-US" sz="1300" dirty="0"/>
+              <a:t>Partial fine-tuning is 5 and 3 points behind full at 1 and 2 labels, then equal. CLIP beats the ImageNet ViT only at 1 label (+8.4 pts).</a:t>
+            </a:r>
+            <a:endParaRPr lang="en-US" sz="1200" dirty="0"/>
+          </a:p>
+        </p:txBody>
+      </p:sp>
+      <p:sp>
+        <p:nvSpPr>
+          <p:cNvPr id="14" name="Text 11"/>
+          <p:cNvSpPr txBox="1"/>
+          <p:nvPr/>
+        </p:nvSpPr>
+        <p:spPr>
+          <a:xfrm>
+            <a:off x="457200" y="4754880"/>
+            <a:ext cx="7772400" cy="228600"/>
+          </a:xfrm>
+          <a:prstGeom prst="rect">
+            <a:avLst/>
+          </a:prstGeom>
+          <a:noFill/>
+          <a:ln/>
+        </p:spPr>
+        <p:txBody>
+          <a:bodyPr wrap="square" lIns="0" tIns="0" rIns="0" bIns="0" rtlCol="0" anchor="t"/>
+          <a:lstStyle/>
+          <a:p>
+            <a:pPr indent="0" marL="0">
+              <a:buNone/>
+            </a:pPr>
+            <a:r>
+              <a:rPr lang="en-US" sz="900" dirty="0">
+                <a:solidFill>
+                  <a:schemeClr val="accent3"/>
+                </a:solidFill>
+                <a:latin typeface="Calibri" pitchFamily="34" charset="0"/>
+                <a:ea typeface="Calibri" pitchFamily="34" charset="-122"/>
+                <a:cs typeface="Calibri" pitchFamily="34" charset="-120"/>
+              </a:rPr>
+              <a:t>Mean over 5 folds, shaded band is one SD. Intervals are approximate because folds share training images.</a:t>
+            </a:r>
+            <a:endParaRPr lang="en-US" sz="900" dirty="0"/>
           </a:p>
         </p:txBody>
       </p:sp>
@@ -4691,7 +5448,7 @@
                   <a:srgbClr val="1F2A33"/>
                 </a:solidFill>
               </a:rPr>
-              <a:t>Robustness is not automatic, and deployment needs human oversight</a:t>
+              <a:t>Beyond accuracy: rare defects, unseen defects and confident mistakes</a:t>
             </a:r>
             <a:endParaRPr lang="en-US" sz="2400" dirty="0"/>
           </a:p>
@@ -4699,7 +5456,7 @@
       </p:sp>
       <p:pic>
         <p:nvPicPr>
-          <p:cNvPr id="3" name="Image 0" descr="/home/claude/fig/fig4_robustness.png">    </p:cNvPr>
+          <p:cNvPr id="3" name="Image 0" descr="/home/claude/fig/fig2_rare_defect.png">    </p:cNvPr>
           <p:cNvPicPr>
             <a:picLocks noChangeAspect="1"/>
           </p:cNvPicPr>
@@ -4714,7 +5471,7 @@
         <p:spPr>
           <a:xfrm>
             <a:off x="365760" y="1188720"/>
-            <a:ext cx="4937760" cy="2057400"/>
+            <a:ext cx="4480560" cy="2167128"/>
           </a:xfrm>
           <a:prstGeom prst="rect">
             <a:avLst/>
@@ -4729,34 +5486,34 @@
         </p:nvSpPr>
         <p:spPr>
           <a:xfrm>
-            <a:off x="457200" y="3337560"/>
-            <a:ext cx="4754880" cy="822960"/>
-          </a:xfrm>
-          <a:prstGeom prst="rect">
-            <a:avLst/>
-          </a:prstGeom>
-          <a:noFill/>
-          <a:ln/>
-        </p:spPr>
-        <p:txBody>
-          <a:bodyPr wrap="square" lIns="0" tIns="0" rIns="0" bIns="0" rtlCol="0" anchor="t"/>
-          <a:lstStyle/>
-          <a:p>
-            <a:pPr indent="0" marL="0">
-              <a:buNone/>
-            </a:pPr>
-            <a:r>
-              <a:rPr lang="en-US" sz="1200" dirty="0">
-                <a:solidFill>
-                  <a:schemeClr val="tx1"/>
+            <a:off x="457200" y="3401568"/>
+            <a:ext cx="4389120" cy="457200"/>
+          </a:xfrm>
+          <a:prstGeom prst="rect">
+            <a:avLst/>
+          </a:prstGeom>
+          <a:noFill/>
+          <a:ln/>
+        </p:spPr>
+        <p:txBody>
+          <a:bodyPr wrap="square" lIns="0" tIns="0" rIns="0" bIns="0" rtlCol="0" anchor="t"/>
+          <a:lstStyle/>
+          <a:p>
+            <a:pPr indent="0" marL="0">
+              <a:buNone/>
+            </a:pPr>
+            <a:r>
+              <a:rPr lang="en-US" sz="1100" i="1" dirty="0">
+                <a:solidFill>
+                  <a:schemeClr val="accent3"/>
                 </a:solidFill>
                 <a:latin typeface="Calibri" pitchFamily="34" charset="0"/>
                 <a:ea typeface="Calibri" pitchFamily="34" charset="-122"/>
                 <a:cs typeface="Calibri" pitchFamily="34" charset="-120"/>
               </a:rPr>
-              <a:t>Heaviest blur: 61% (fine-tuned CLIP) to 97% with blur and noise augmentation. The gain applies only to distortions seen in training; brightness got slightly worse.</a:t>
-            </a:r>
-            <a:endParaRPr lang="en-US" sz="1200" dirty="0"/>
+              <a:t>Recall for a rare defect with 1, 5 or 20 labelled examples (others have 50)</a:t>
+            </a:r>
+            <a:endParaRPr lang="en-US" sz="1100" dirty="0"/>
           </a:p>
         </p:txBody>
       </p:sp>
@@ -4768,12 +5525,12 @@
         </p:nvSpPr>
         <p:spPr>
           <a:xfrm>
-            <a:off x="5486400" y="1188720"/>
-            <a:ext cx="3291840" cy="3246120"/>
+            <a:off x="5029200" y="1188720"/>
+            <a:ext cx="3749040" cy="960120"/>
           </a:xfrm>
           <a:prstGeom prst="roundRect">
             <a:avLst>
-              <a:gd name="adj" fmla="val 2254"/>
+              <a:gd name="adj" fmla="val 7619"/>
             </a:avLst>
           </a:prstGeom>
           <a:solidFill>
@@ -4795,34 +5552,34 @@
         </p:nvSpPr>
         <p:spPr>
           <a:xfrm>
-            <a:off x="5669280" y="1298448"/>
-            <a:ext cx="3017520" cy="320040"/>
-          </a:xfrm>
-          <a:prstGeom prst="rect">
-            <a:avLst/>
-          </a:prstGeom>
-          <a:noFill/>
-          <a:ln/>
-        </p:spPr>
-        <p:txBody>
-          <a:bodyPr wrap="square" lIns="0" tIns="0" rIns="0" bIns="0" rtlCol="0" anchor="t"/>
-          <a:lstStyle/>
-          <a:p>
-            <a:pPr indent="0" marL="0">
-              <a:buNone/>
-            </a:pPr>
-            <a:r>
-              <a:rPr lang="en-US" sz="1400" b="1" dirty="0">
-                <a:solidFill>
-                  <a:schemeClr val="accent1"/>
+            <a:off x="5166360" y="1261872"/>
+            <a:ext cx="3474720" cy="457200"/>
+          </a:xfrm>
+          <a:prstGeom prst="rect">
+            <a:avLst/>
+          </a:prstGeom>
+          <a:noFill/>
+          <a:ln/>
+        </p:spPr>
+        <p:txBody>
+          <a:bodyPr wrap="square" lIns="0" tIns="0" rIns="0" bIns="0" rtlCol="0" anchor="t"/>
+          <a:lstStyle/>
+          <a:p>
+            <a:pPr indent="0" marL="0">
+              <a:buNone/>
+            </a:pPr>
+            <a:r>
+              <a:rPr lang="en-US" sz="2400" b="1" dirty="0">
+                <a:solidFill>
+                  <a:schemeClr val="accent2"/>
                 </a:solidFill>
                 <a:latin typeface="Cambria" pitchFamily="34" charset="0"/>
                 <a:ea typeface="Cambria" pitchFamily="34" charset="-122"/>
                 <a:cs typeface="Cambria" pitchFamily="34" charset="-120"/>
               </a:rPr>
-              <a:t>Ethical and societal points</a:t>
-            </a:r>
-            <a:endParaRPr lang="en-US" sz="1400" dirty="0"/>
+              <a:t>69% vs 6%</a:t>
+            </a:r>
+            <a:endParaRPr lang="en-US" sz="2400" dirty="0"/>
           </a:p>
         </p:txBody>
       </p:sp>
@@ -4834,25 +5591,21 @@
         </p:nvSpPr>
         <p:spPr>
           <a:xfrm>
-            <a:off x="5669280" y="1691640"/>
-            <a:ext cx="3017520" cy="2697480"/>
-          </a:xfrm>
-          <a:prstGeom prst="rect">
-            <a:avLst/>
-          </a:prstGeom>
-          <a:noFill/>
-          <a:ln/>
-        </p:spPr>
-        <p:txBody>
-          <a:bodyPr wrap="square" lIns="0" tIns="0" rIns="0" bIns="0" rtlCol="0" anchor="t"/>
-          <a:lstStyle/>
-          <a:p>
-            <a:pPr marL="342900" indent="-342900">
-              <a:spcAft>
-                <a:spcPts val="400"/>
-              </a:spcAft>
-              <a:buSzPct val="100000"/>
-              <a:buChar char="•"/>
+            <a:off x="5166360" y="1719072"/>
+            <a:ext cx="3474720" cy="393192"/>
+          </a:xfrm>
+          <a:prstGeom prst="rect">
+            <a:avLst/>
+          </a:prstGeom>
+          <a:noFill/>
+          <a:ln/>
+        </p:spPr>
+        <p:txBody>
+          <a:bodyPr wrap="square" lIns="0" tIns="0" rIns="0" bIns="0" rtlCol="0" anchor="t"/>
+          <a:lstStyle/>
+          <a:p>
+            <a:pPr indent="0" marL="0">
+              <a:buNone/>
             </a:pPr>
             <a:r>
               <a:rPr lang="en-US" sz="1100" dirty="0">
@@ -4863,17 +5616,101 @@
                 <a:ea typeface="Calibri" pitchFamily="34" charset="-122"/>
                 <a:cs typeface="Calibri" pitchFamily="34" charset="-120"/>
               </a:rPr>
-              <a:t>Human review of low-confidence and novel items; log every decision</a:t>
+              <a:t>rare-defect recall at 1 example: class-weighted vs plain fine-tuning</a:t>
             </a:r>
             <a:endParaRPr lang="en-US" sz="1100" dirty="0"/>
           </a:p>
-          <a:p>
-            <a:pPr marL="342900" indent="-342900">
-              <a:spcAft>
-                <a:spcPts val="400"/>
-              </a:spcAft>
-              <a:buSzPct val="100000"/>
-              <a:buChar char="•"/>
+        </p:txBody>
+      </p:sp>
+      <p:sp>
+        <p:nvSpPr>
+          <p:cNvPr id="8" name="Shape 5"/>
+          <p:cNvSpPr/>
+          <p:nvPr/>
+        </p:nvSpPr>
+        <p:spPr>
+          <a:xfrm>
+            <a:off x="5029200" y="2286000"/>
+            <a:ext cx="3749040" cy="960120"/>
+          </a:xfrm>
+          <a:prstGeom prst="roundRect">
+            <a:avLst>
+              <a:gd name="adj" fmla="val 7619"/>
+            </a:avLst>
+          </a:prstGeom>
+          <a:solidFill>
+            <a:schemeClr val="bg2"/>
+          </a:solidFill>
+          <a:ln w="12700">
+            <a:solidFill>
+              <a:schemeClr val="bg2"/>
+            </a:solidFill>
+            <a:prstDash val="solid"/>
+          </a:ln>
+        </p:spPr>
+      </p:sp>
+      <p:sp>
+        <p:nvSpPr>
+          <p:cNvPr id="9" name="Text 6"/>
+          <p:cNvSpPr txBox="1"/>
+          <p:nvPr/>
+        </p:nvSpPr>
+        <p:spPr>
+          <a:xfrm>
+            <a:off x="5166360" y="2359152"/>
+            <a:ext cx="3474720" cy="457200"/>
+          </a:xfrm>
+          <a:prstGeom prst="rect">
+            <a:avLst/>
+          </a:prstGeom>
+          <a:noFill/>
+          <a:ln/>
+        </p:spPr>
+        <p:txBody>
+          <a:bodyPr wrap="square" lIns="0" tIns="0" rIns="0" bIns="0" rtlCol="0" anchor="t"/>
+          <a:lstStyle/>
+          <a:p>
+            <a:pPr indent="0" marL="0">
+              <a:buNone/>
+            </a:pPr>
+            <a:r>
+              <a:rPr lang="en-US" sz="2400" b="1" dirty="0">
+                <a:solidFill>
+                  <a:schemeClr val="accent1"/>
+                </a:solidFill>
+                <a:latin typeface="Cambria" pitchFamily="34" charset="0"/>
+                <a:ea typeface="Cambria" pitchFamily="34" charset="-122"/>
+                <a:cs typeface="Cambria" pitchFamily="34" charset="-120"/>
+              </a:rPr>
+              <a:t>0.963 vs 0.866</a:t>
+            </a:r>
+            <a:endParaRPr lang="en-US" sz="2400" dirty="0"/>
+          </a:p>
+        </p:txBody>
+      </p:sp>
+      <p:sp>
+        <p:nvSpPr>
+          <p:cNvPr id="10" name="Text 7"/>
+          <p:cNvSpPr txBox="1"/>
+          <p:nvPr/>
+        </p:nvSpPr>
+        <p:spPr>
+          <a:xfrm>
+            <a:off x="5166360" y="2816352"/>
+            <a:ext cx="3474720" cy="393192"/>
+          </a:xfrm>
+          <a:prstGeom prst="rect">
+            <a:avLst/>
+          </a:prstGeom>
+          <a:noFill/>
+          <a:ln/>
+        </p:spPr>
+        <p:txBody>
+          <a:bodyPr wrap="square" lIns="0" tIns="0" rIns="0" bIns="0" rtlCol="0" anchor="t"/>
+          <a:lstStyle/>
+          <a:p>
+            <a:pPr indent="0" marL="0">
+              <a:buNone/>
             </a:pPr>
             <a:r>
               <a:rPr lang="en-US" sz="1100" dirty="0">
@@ -4884,17 +5721,101 @@
                 <a:ea typeface="Calibri" pitchFamily="34" charset="-122"/>
                 <a:cs typeface="Calibri" pitchFamily="34" charset="-120"/>
               </a:rPr>
-              <a:t>Revalidate on each plant: one lab, one camera here</a:t>
+              <a:t>AUROC for spotting a never-seen defect: fine-tuned vs frozen</a:t>
             </a:r>
             <a:endParaRPr lang="en-US" sz="1100" dirty="0"/>
           </a:p>
-          <a:p>
-            <a:pPr marL="342900" indent="-342900">
-              <a:spcAft>
-                <a:spcPts val="400"/>
-              </a:spcAft>
-              <a:buSzPct val="100000"/>
-              <a:buChar char="•"/>
+        </p:txBody>
+      </p:sp>
+      <p:sp>
+        <p:nvSpPr>
+          <p:cNvPr id="11" name="Shape 8"/>
+          <p:cNvSpPr/>
+          <p:nvPr/>
+        </p:nvSpPr>
+        <p:spPr>
+          <a:xfrm>
+            <a:off x="5029200" y="3383280"/>
+            <a:ext cx="3749040" cy="960120"/>
+          </a:xfrm>
+          <a:prstGeom prst="roundRect">
+            <a:avLst>
+              <a:gd name="adj" fmla="val 7619"/>
+            </a:avLst>
+          </a:prstGeom>
+          <a:solidFill>
+            <a:schemeClr val="bg2"/>
+          </a:solidFill>
+          <a:ln w="12700">
+            <a:solidFill>
+              <a:schemeClr val="bg2"/>
+            </a:solidFill>
+            <a:prstDash val="solid"/>
+          </a:ln>
+        </p:spPr>
+      </p:sp>
+      <p:sp>
+        <p:nvSpPr>
+          <p:cNvPr id="12" name="Text 9"/>
+          <p:cNvSpPr txBox="1"/>
+          <p:nvPr/>
+        </p:nvSpPr>
+        <p:spPr>
+          <a:xfrm>
+            <a:off x="5166360" y="3456432"/>
+            <a:ext cx="3474720" cy="457200"/>
+          </a:xfrm>
+          <a:prstGeom prst="rect">
+            <a:avLst/>
+          </a:prstGeom>
+          <a:noFill/>
+          <a:ln/>
+        </p:spPr>
+        <p:txBody>
+          <a:bodyPr wrap="square" lIns="0" tIns="0" rIns="0" bIns="0" rtlCol="0" anchor="t"/>
+          <a:lstStyle/>
+          <a:p>
+            <a:pPr indent="0" marL="0">
+              <a:buNone/>
+            </a:pPr>
+            <a:r>
+              <a:rPr lang="en-US" sz="2400" b="1" dirty="0">
+                <a:solidFill>
+                  <a:schemeClr val="accent6"/>
+                </a:solidFill>
+                <a:latin typeface="Cambria" pitchFamily="34" charset="0"/>
+                <a:ea typeface="Cambria" pitchFamily="34" charset="-122"/>
+                <a:cs typeface="Cambria" pitchFamily="34" charset="-120"/>
+              </a:rPr>
+              <a:t>22%</a:t>
+            </a:r>
+            <a:endParaRPr lang="en-US" sz="2400" dirty="0"/>
+          </a:p>
+        </p:txBody>
+      </p:sp>
+      <p:sp>
+        <p:nvSpPr>
+          <p:cNvPr id="13" name="Text 10"/>
+          <p:cNvSpPr txBox="1"/>
+          <p:nvPr/>
+        </p:nvSpPr>
+        <p:spPr>
+          <a:xfrm>
+            <a:off x="5166360" y="3913632"/>
+            <a:ext cx="3474720" cy="393192"/>
+          </a:xfrm>
+          <a:prstGeom prst="rect">
+            <a:avLst/>
+          </a:prstGeom>
+          <a:noFill/>
+          <a:ln/>
+        </p:spPr>
+        <p:txBody>
+          <a:bodyPr wrap="square" lIns="0" tIns="0" rIns="0" bIns="0" rtlCol="0" anchor="t"/>
+          <a:lstStyle/>
+          <a:p>
+            <a:pPr indent="0" marL="0">
+              <a:buNone/>
             </a:pPr>
             <a:r>
               <a:rPr lang="en-US" sz="1100" dirty="0">
@@ -4905,20 +5826,38 @@
                 <a:ea typeface="Calibri" pitchFamily="34" charset="-122"/>
                 <a:cs typeface="Calibri" pitchFamily="34" charset="-120"/>
               </a:rPr>
-              <a:t>No people in the images; cameras on a shop floor would bring data-protection duties</a:t>
+              <a:t>of the fine-tuned model's errors at 1 label are made with 90%+ confidence</a:t>
             </a:r>
             <a:endParaRPr lang="en-US" sz="1100" dirty="0"/>
           </a:p>
-          <a:p>
-            <a:pPr marL="342900" indent="-342900">
-              <a:spcAft>
-                <a:spcPts val="400"/>
-              </a:spcAft>
-              <a:buSzPct val="100000"/>
-              <a:buChar char="•"/>
-            </a:pPr>
-            <a:r>
-              <a:rPr lang="en-US" sz="1100" dirty="0">
+        </p:txBody>
+      </p:sp>
+      <p:sp>
+        <p:nvSpPr>
+          <p:cNvPr id="14" name="Text 11"/>
+          <p:cNvSpPr txBox="1"/>
+          <p:nvPr/>
+        </p:nvSpPr>
+        <p:spPr>
+          <a:xfrm>
+            <a:off x="457200" y="3977640"/>
+            <a:ext cx="4389120" cy="548640"/>
+          </a:xfrm>
+          <a:prstGeom prst="rect">
+            <a:avLst/>
+          </a:prstGeom>
+          <a:noFill/>
+          <a:ln/>
+        </p:spPr>
+        <p:txBody>
+          <a:bodyPr wrap="square" lIns="0" tIns="0" rIns="0" bIns="0" rtlCol="0" anchor="t"/>
+          <a:lstStyle/>
+          <a:p>
+            <a:pPr indent="0" marL="0">
+              <a:buNone/>
+            </a:pPr>
+            <a:r>
+              <a:rPr lang="en-US" sz="1300" b="1" dirty="0">
                 <a:solidFill>
                   <a:schemeClr val="tx1"/>
                 </a:solidFill>
@@ -4926,30 +5865,9 @@
                 <a:ea typeface="Calibri" pitchFamily="34" charset="-122"/>
                 <a:cs typeface="Calibri" pitchFamily="34" charset="-120"/>
               </a:rPr>
-              <a:t>Assist inspectors rather than replace them; the UAE AI strategy flags manufacturing for automation</a:t>
-            </a:r>
-            <a:endParaRPr lang="en-US" sz="1100" dirty="0"/>
-          </a:p>
-          <a:p>
-            <a:pPr marL="342900" indent="-342900">
-              <a:spcAft>
-                <a:spcPts val="400"/>
-              </a:spcAft>
-              <a:buSzPct val="100000"/>
-              <a:buChar char="•"/>
-            </a:pPr>
-            <a:r>
-              <a:rPr lang="en-US" sz="1100" dirty="0">
-                <a:solidFill>
-                  <a:schemeClr val="tx1"/>
-                </a:solidFill>
-                <a:latin typeface="Calibri" pitchFamily="34" charset="0"/>
-                <a:ea typeface="Calibri" pitchFamily="34" charset="-122"/>
-                <a:cs typeface="Calibri" pitchFamily="34" charset="-120"/>
-              </a:rPr>
-              <a:t>Fine-tuning costs far more compute than frozen features</a:t>
-            </a:r>
-            <a:endParaRPr lang="en-US" sz="1100" dirty="0"/>
+              <a:t>Good average calibration does not make a confident prediction trustworthy.</a:t>
+            </a:r>
+            <a:endParaRPr lang="en-US" sz="1300" dirty="0"/>
           </a:p>
         </p:txBody>
       </p:sp>
@@ -5026,6 +5944,370 @@
       <p:sp>
         <p:nvSpPr>
           <p:cNvPr id="2" name="Text 0"/>
+          <p:cNvSpPr/>
+          <p:nvPr>
+            <p:ph idx="100" type="title" hasCustomPrompt="1"/>
+          </p:nvPr>
+        </p:nvSpPr>
+        <p:spPr>
+          <a:xfrm>
+            <a:off x="457200" y="228600"/>
+            <a:ext cx="8229600" cy="777240"/>
+          </a:xfrm>
+          <a:prstGeom prst="rect">
+            <a:avLst/>
+          </a:prstGeom>
+          <a:noFill/>
+          <a:ln/>
+        </p:spPr>
+        <p:txBody>
+          <a:bodyPr wrap="square" lIns="0" tIns="0" rIns="0" bIns="0" rtlCol="0" anchor="ctr"/>
+          <a:lstStyle/>
+          <a:p>
+            <a:pPr algn="l" indent="0" marL="0">
+              <a:buNone/>
+            </a:pPr>
+            <a:r>
+              <a:rPr lang="en-US" sz="2400" b="1" dirty="0">
+                <a:solidFill>
+                  <a:srgbClr val="1F2A33"/>
+                </a:solidFill>
+              </a:rPr>
+              <a:t>Robustness is not automatic, and deployment needs human oversight</a:t>
+            </a:r>
+            <a:endParaRPr lang="en-US" sz="2400" dirty="0"/>
+          </a:p>
+        </p:txBody>
+      </p:sp>
+      <p:pic>
+        <p:nvPicPr>
+          <p:cNvPr id="3" name="Image 0" descr="/home/claude/fig/fig4_robustness.png">    </p:cNvPr>
+          <p:cNvPicPr>
+            <a:picLocks noChangeAspect="1"/>
+          </p:cNvPicPr>
+          <p:nvPr/>
+        </p:nvPicPr>
+        <p:blipFill>
+          <a:blip r:embed="rId1"/>
+          <a:stretch>
+            <a:fillRect/>
+          </a:stretch>
+        </p:blipFill>
+        <p:spPr>
+          <a:xfrm>
+            <a:off x="365760" y="1188720"/>
+            <a:ext cx="4937760" cy="2057400"/>
+          </a:xfrm>
+          <a:prstGeom prst="rect">
+            <a:avLst/>
+          </a:prstGeom>
+        </p:spPr>
+      </p:pic>
+      <p:sp>
+        <p:nvSpPr>
+          <p:cNvPr id="4" name="Text 1"/>
+          <p:cNvSpPr txBox="1"/>
+          <p:nvPr/>
+        </p:nvSpPr>
+        <p:spPr>
+          <a:xfrm>
+            <a:off x="457200" y="3337560"/>
+            <a:ext cx="4754880" cy="822960"/>
+          </a:xfrm>
+          <a:prstGeom prst="rect">
+            <a:avLst/>
+          </a:prstGeom>
+          <a:noFill/>
+          <a:ln/>
+        </p:spPr>
+        <p:txBody>
+          <a:bodyPr wrap="square" lIns="0" tIns="0" rIns="0" bIns="0" rtlCol="0" anchor="t"/>
+          <a:lstStyle/>
+          <a:p>
+            <a:pPr indent="0" marL="0">
+              <a:buNone/>
+            </a:pPr>
+            <a:r>
+              <a:rPr lang="en-US" sz="1200" dirty="0">
+                <a:solidFill>
+                  <a:schemeClr val="tx1"/>
+                </a:solidFill>
+                <a:latin typeface="Calibri" pitchFamily="34" charset="0"/>
+                <a:ea typeface="Calibri" pitchFamily="34" charset="-122"/>
+                <a:cs typeface="Calibri" pitchFamily="34" charset="-120"/>
+              </a:rPr>
+              <a:t>Heaviest blur: 61% (fine-tuned CLIP) to 97% with blur and noise augmentation. The gain applies only to distortions seen in training; brightness got slightly worse.</a:t>
+            </a:r>
+            <a:endParaRPr lang="en-US" sz="1200" dirty="0"/>
+          </a:p>
+        </p:txBody>
+      </p:sp>
+      <p:sp>
+        <p:nvSpPr>
+          <p:cNvPr id="5" name="Shape 2"/>
+          <p:cNvSpPr/>
+          <p:nvPr/>
+        </p:nvSpPr>
+        <p:spPr>
+          <a:xfrm>
+            <a:off x="5486400" y="1188720"/>
+            <a:ext cx="3291840" cy="3246120"/>
+          </a:xfrm>
+          <a:prstGeom prst="roundRect">
+            <a:avLst>
+              <a:gd name="adj" fmla="val 2254"/>
+            </a:avLst>
+          </a:prstGeom>
+          <a:solidFill>
+            <a:schemeClr val="bg2"/>
+          </a:solidFill>
+          <a:ln w="12700">
+            <a:solidFill>
+              <a:schemeClr val="bg2"/>
+            </a:solidFill>
+            <a:prstDash val="solid"/>
+          </a:ln>
+        </p:spPr>
+      </p:sp>
+      <p:sp>
+        <p:nvSpPr>
+          <p:cNvPr id="6" name="Text 3"/>
+          <p:cNvSpPr txBox="1"/>
+          <p:nvPr/>
+        </p:nvSpPr>
+        <p:spPr>
+          <a:xfrm>
+            <a:off x="5669280" y="1298448"/>
+            <a:ext cx="3017520" cy="320040"/>
+          </a:xfrm>
+          <a:prstGeom prst="rect">
+            <a:avLst/>
+          </a:prstGeom>
+          <a:noFill/>
+          <a:ln/>
+        </p:spPr>
+        <p:txBody>
+          <a:bodyPr wrap="square" lIns="0" tIns="0" rIns="0" bIns="0" rtlCol="0" anchor="t"/>
+          <a:lstStyle/>
+          <a:p>
+            <a:pPr indent="0" marL="0">
+              <a:buNone/>
+            </a:pPr>
+            <a:r>
+              <a:rPr lang="en-US" sz="1400" b="1" dirty="0">
+                <a:solidFill>
+                  <a:schemeClr val="accent1"/>
+                </a:solidFill>
+                <a:latin typeface="Cambria" pitchFamily="34" charset="0"/>
+                <a:ea typeface="Cambria" pitchFamily="34" charset="-122"/>
+                <a:cs typeface="Cambria" pitchFamily="34" charset="-120"/>
+              </a:rPr>
+              <a:t>Ethical and societal points</a:t>
+            </a:r>
+            <a:endParaRPr lang="en-US" sz="1400" dirty="0"/>
+          </a:p>
+        </p:txBody>
+      </p:sp>
+      <p:sp>
+        <p:nvSpPr>
+          <p:cNvPr id="7" name="Text 4"/>
+          <p:cNvSpPr txBox="1"/>
+          <p:nvPr/>
+        </p:nvSpPr>
+        <p:spPr>
+          <a:xfrm>
+            <a:off x="5669280" y="1691640"/>
+            <a:ext cx="3017520" cy="2697480"/>
+          </a:xfrm>
+          <a:prstGeom prst="rect">
+            <a:avLst/>
+          </a:prstGeom>
+          <a:noFill/>
+          <a:ln/>
+        </p:spPr>
+        <p:txBody>
+          <a:bodyPr wrap="square" lIns="0" tIns="0" rIns="0" bIns="0" rtlCol="0" anchor="t"/>
+          <a:lstStyle/>
+          <a:p>
+            <a:pPr marL="342900" indent="-342900">
+              <a:spcAft>
+                <a:spcPts val="400"/>
+              </a:spcAft>
+              <a:buSzPct val="100000"/>
+              <a:buChar char="•"/>
+            </a:pPr>
+            <a:r>
+              <a:rPr lang="en-US" sz="1100" dirty="0">
+                <a:solidFill>
+                  <a:schemeClr val="tx1"/>
+                </a:solidFill>
+                <a:latin typeface="Calibri" pitchFamily="34" charset="0"/>
+                <a:ea typeface="Calibri" pitchFamily="34" charset="-122"/>
+                <a:cs typeface="Calibri" pitchFamily="34" charset="-120"/>
+              </a:rPr>
+              <a:t>Human review of low-confidence and novel items; log every decision</a:t>
+            </a:r>
+            <a:endParaRPr lang="en-US" sz="1100" dirty="0"/>
+          </a:p>
+          <a:p>
+            <a:pPr marL="342900" indent="-342900">
+              <a:spcAft>
+                <a:spcPts val="400"/>
+              </a:spcAft>
+              <a:buSzPct val="100000"/>
+              <a:buChar char="•"/>
+            </a:pPr>
+            <a:r>
+              <a:rPr lang="en-US" sz="1100" dirty="0">
+                <a:solidFill>
+                  <a:schemeClr val="tx1"/>
+                </a:solidFill>
+                <a:latin typeface="Calibri" pitchFamily="34" charset="0"/>
+                <a:ea typeface="Calibri" pitchFamily="34" charset="-122"/>
+                <a:cs typeface="Calibri" pitchFamily="34" charset="-120"/>
+              </a:rPr>
+              <a:t>Revalidate on each plant: one lab, one camera here</a:t>
+            </a:r>
+            <a:endParaRPr lang="en-US" sz="1100" dirty="0"/>
+          </a:p>
+          <a:p>
+            <a:pPr marL="342900" indent="-342900">
+              <a:spcAft>
+                <a:spcPts val="400"/>
+              </a:spcAft>
+              <a:buSzPct val="100000"/>
+              <a:buChar char="•"/>
+            </a:pPr>
+            <a:r>
+              <a:rPr lang="en-US" sz="1100" dirty="0">
+                <a:solidFill>
+                  <a:schemeClr val="tx1"/>
+                </a:solidFill>
+                <a:latin typeface="Calibri" pitchFamily="34" charset="0"/>
+                <a:ea typeface="Calibri" pitchFamily="34" charset="-122"/>
+                <a:cs typeface="Calibri" pitchFamily="34" charset="-120"/>
+              </a:rPr>
+              <a:t>No people in the images; cameras on a shop floor would bring data-protection duties</a:t>
+            </a:r>
+            <a:endParaRPr lang="en-US" sz="1100" dirty="0"/>
+          </a:p>
+          <a:p>
+            <a:pPr marL="342900" indent="-342900">
+              <a:spcAft>
+                <a:spcPts val="400"/>
+              </a:spcAft>
+              <a:buSzPct val="100000"/>
+              <a:buChar char="•"/>
+            </a:pPr>
+            <a:r>
+              <a:rPr lang="en-US" sz="1100" dirty="0">
+                <a:solidFill>
+                  <a:schemeClr val="tx1"/>
+                </a:solidFill>
+                <a:latin typeface="Calibri" pitchFamily="34" charset="0"/>
+                <a:ea typeface="Calibri" pitchFamily="34" charset="-122"/>
+                <a:cs typeface="Calibri" pitchFamily="34" charset="-120"/>
+              </a:rPr>
+              <a:t>Assist inspectors rather than replace them; the UAE AI strategy flags manufacturing for automation</a:t>
+            </a:r>
+            <a:endParaRPr lang="en-US" sz="1100" dirty="0"/>
+          </a:p>
+          <a:p>
+            <a:pPr marL="342900" indent="-342900">
+              <a:spcAft>
+                <a:spcPts val="400"/>
+              </a:spcAft>
+              <a:buSzPct val="100000"/>
+              <a:buChar char="•"/>
+            </a:pPr>
+            <a:r>
+              <a:rPr lang="en-US" sz="1100" dirty="0">
+                <a:solidFill>
+                  <a:schemeClr val="tx1"/>
+                </a:solidFill>
+                <a:latin typeface="Calibri" pitchFamily="34" charset="0"/>
+                <a:ea typeface="Calibri" pitchFamily="34" charset="-122"/>
+                <a:cs typeface="Calibri" pitchFamily="34" charset="-120"/>
+              </a:rPr>
+              <a:t>Fine-tuning costs far more compute than frozen features</a:t>
+            </a:r>
+            <a:endParaRPr lang="en-US" sz="1100" dirty="0"/>
+          </a:p>
+        </p:txBody>
+      </p:sp>
+      <p:sp>
+        <p:nvSpPr>
+          <p:cNvPr id="25" name="Slide Number Placeholder 0"/>
+          <p:cNvSpPr>
+            <a:spLocks noGrp="1"/>
+          </p:cNvSpPr>
+          <p:nvPr>
+            <p:ph type="sldNum" sz="quarter" idx="4294967295"/>
+          </p:nvPr>
+        </p:nvSpPr>
+        <p:spPr>
+          <a:xfrm>
+            <a:off x="8412480" y="4754880"/>
+            <a:ext cx="457200" cy="274320"/>
+          </a:xfrm>
+          <a:prstGeom prst="rect">
+            <a:avLst/>
+          </a:prstGeom>
+          <a:extLst>
+            <a:ext uri="{C572A759-6A51-4108-AA02-DFA0A04FC94B}">
+              <ma14:wrappingTextBoxFlag xmlns:ma14="http://schemas.microsoft.com/office/mac/drawingml/2011/main" val="0"/>
+            </a:ext>
+          </a:extLst>
+        </p:spPr>
+        <p:txBody>
+          <a:bodyPr/>
+          <a:lstStyle>
+            <a:lvl1pPr>
+              <a:defRPr sz="1000">
+                <a:solidFill>
+                  <a:srgbClr val="7A8B99"/>
+                </a:solidFill>
+              </a:defRPr>
+            </a:lvl1pPr>
+          </a:lstStyle>
+          <a:p>
+            <a:pPr algn="r"/>
+            <a:fld id="{F7021451-1387-4CA6-816F-3879F97B5CBC}" type="slidenum">
+              <a:rPr b="0" lang="en-US"/>
+              <a:t>7</a:t>
+            </a:fld>
+            <a:endParaRPr lang="en-US"/>
+          </a:p>
+        </p:txBody>
+      </p:sp>
+    </p:spTree>
+  </p:cSld>
+  <p:clrMapOvr>
+    <a:masterClrMapping/>
+  </p:clrMapOvr>
+</p:sld>
+</file>
+
+<file path=ppt/slides/slide8.xml><?xml version="1.0" encoding="utf-8"?>
+<p:sld xmlns:a="http://schemas.openxmlformats.org/drawingml/2006/main" xmlns:r="http://schemas.openxmlformats.org/officeDocument/2006/relationships" xmlns:p="http://schemas.openxmlformats.org/presentationml/2006/main">
+  <p:cSld name="Slide 8">
+    <p:spTree>
+      <p:nvGrpSpPr>
+        <p:cNvPr id="1" name=""/>
+        <p:cNvGrpSpPr/>
+        <p:nvPr/>
+      </p:nvGrpSpPr>
+      <p:grpSpPr>
+        <a:xfrm>
+          <a:off x="0" y="0"/>
+          <a:ext cx="0" cy="0"/>
+          <a:chOff x="0" y="0"/>
+          <a:chExt cx="0" cy="0"/>
+        </a:xfrm>
+      </p:grpSpPr>
+      <p:sp>
+        <p:nvSpPr>
+          <p:cNvPr id="2" name="Text 0"/>
           <p:cNvSpPr txBox="1"/>
           <p:nvPr/>
         </p:nvSpPr>
@@ -5733,7 +7015,7 @@
                 <a:ea typeface="Calibri" pitchFamily="34" charset="-122"/>
                 <a:cs typeface="Calibri" pitchFamily="34" charset="-120"/>
               </a:rPr>
-              <a:t>Code, results and report: GitHub repository (link in the report)</a:t>
+              <a:t>Code, results and report: github.com/kk917/neu-vit-steel-defects</a:t>
             </a:r>
             <a:endParaRPr lang="en-US" sz="1000" dirty="0"/>
           </a:p>

</xml_diff>